<commit_message>
Update Slide 3 objectives to match official document verbatim
</commit_message>
<xml_diff>
--- a/qsbg_smart_tour_presentation.pptx
+++ b/qsbg_smart_tour_presentation.pptx
@@ -994,7 +994,17 @@
           </a:p>
           <a:p>
             <a:r>
-              <a:t>วัตถุประสงค์หลักของโครงการจึงแบ่งออกเป็น 2 มิติสำคัญ: มิติแรกคือการสร้าง Digital Foundation วางระบบข้อมูลสารสนเทศที่สมบูรณ์แบบ มิติที่สองคือการพัฒนา Application Suite เชื่อมโยงทุกคนเข้าด้วยกัน ทั้งนักท่องเที่ยว พนักงานขับรถ เจ้าหน้าที่ และผู้บริหารครับ</a:t>
+              <a:t>สำหรับวัตถุประสงค์หลักของโครงการ มี 2 ประการตามกรอบการดำเนินงานครับ:</a:t>
+            </a:r>
+          </a:p>
+          <a:p>
+            <a:r>
+              <a:t>ข้อที่ 1 คือ เพื่อวิเคราะห์และออกแบบระบบการจัดการข้อมูลสารสนเทศรถนำเที่ยวไฟฟ้าเพื่อการบริหารงานของสวนพฤกษศาสตร์สมเด็จพระนางเจ้าสิริกิติ์ จังหวัดเชียงใหม่ เพื่อวางรากฐานระบบสารสนเทศที่มีประสิทธิภาพสูงสุด</a:t>
+            </a:r>
+          </a:p>
+          <a:p>
+            <a:r>
+              <a:t>และข้อที่ 2 คือ เพื่อพัฒนาแอปพลิเคชันระบบการจัดการรถนำเที่ยวไฟฟ้าของสวนพฤกษศาสตร์สมเด็จพระนางเจ้าสิริกิติ์ จังหวัดเชียงใหม่ ให้ครอบคลุมทั้งระบบจำหน่ายตั๋ว e-Ticket, การติดตามตำแหน่งรถ, การจัดคิว และแดชบอร์ดบริหารจัดการอย่างครบวงจรครับ</a:t>
             </a:r>
           </a:p>
         </p:txBody>
@@ -8033,9 +8043,9 @@
           <a:p>
             <a:pPr>
               <a:spcAft>
-                <a:spcPts val="1600"/>
-              </a:spcAft>
-              <a:defRPr sz="1800" b="1">
+                <a:spcPts val="2000"/>
+              </a:spcAft>
+              <a:defRPr sz="1900" b="1">
                 <a:solidFill>
                   <a:srgbClr val="1B4332"/>
                 </a:solidFill>
@@ -8043,12 +8053,15 @@
               </a:defRPr>
             </a:pPr>
             <a:r>
-              <a:t>วัตถุประสงค์หลักของโครงการ</a:t>
-            </a:r>
-          </a:p>
-          <a:p>
-            <a:pPr>
-              <a:defRPr sz="1450" b="1">
+              <a:t>วัตถุประสงค์โครงการ (Project Objectives)</a:t>
+            </a:r>
+          </a:p>
+          <a:p>
+            <a:pPr>
+              <a:spcAft>
+                <a:spcPts val="400"/>
+              </a:spcAft>
+              <a:defRPr sz="1550" b="1">
                 <a:solidFill>
                   <a:srgbClr val="134074"/>
                 </a:solidFill>
@@ -8056,15 +8069,15 @@
               </a:defRPr>
             </a:pPr>
             <a:r>
-              <a:t>1. ศึกษาวิเคราะห์และออกแบบสถาปัตยกรรมข้อมูล</a:t>
-            </a:r>
-          </a:p>
-          <a:p>
-            <a:pPr>
-              <a:spcAft>
-                <a:spcPts val="1400"/>
-              </a:spcAft>
-              <a:defRPr sz="1300">
+              <a:t>1. เพื่อวิเคราะห์และออกแบบระบบการจัดการข้อมูลสารสนเทศ</a:t>
+            </a:r>
+          </a:p>
+          <a:p>
+            <a:pPr>
+              <a:spcAft>
+                <a:spcPts val="2400"/>
+              </a:spcAft>
+              <a:defRPr sz="1350">
                 <a:solidFill>
                   <a:srgbClr val="14181B"/>
                 </a:solidFill>
@@ -8072,12 +8085,15 @@
               </a:defRPr>
             </a:pPr>
             <a:r>
-              <a:t>วิเคราะห์และออกแบบระบบฐานข้อมูลและโครงสร้างสารสนเทศรถนำเที่ยวไฟฟ้า เพื่อการบริหารงานที่มีประสิทธิภาพ</a:t>
-            </a:r>
-          </a:p>
-          <a:p>
-            <a:pPr>
-              <a:defRPr sz="1450" b="1">
+              <a:t>เพื่อวิเคราะห์และออกแบบระบบการจัดการข้อมูลสารสนเทศรถนำเที่ยวไฟฟ้า เพื่อการบริหารงานของสวนพฤกษศาสตร์สมเด็จพระนางเจ้าสิริกิติ์ จังหวัดเชียงใหม่</a:t>
+            </a:r>
+          </a:p>
+          <a:p>
+            <a:pPr>
+              <a:spcAft>
+                <a:spcPts val="400"/>
+              </a:spcAft>
+              <a:defRPr sz="1550" b="1">
                 <a:solidFill>
                   <a:srgbClr val="134074"/>
                 </a:solidFill>
@@ -8085,15 +8101,15 @@
               </a:defRPr>
             </a:pPr>
             <a:r>
-              <a:t>2. พัฒนาระบบแอปพลิเคชันจัดการรถนำเที่ยวครบวงจร</a:t>
-            </a:r>
-          </a:p>
-          <a:p>
-            <a:pPr>
-              <a:spcAft>
-                <a:spcPts val="1400"/>
-              </a:spcAft>
-              <a:defRPr sz="1300">
+              <a:t>2. เพื่อพัฒนาแอปพลิเคชันระบบการจัดการรถนำเที่ยวไฟฟ้า</a:t>
+            </a:r>
+          </a:p>
+          <a:p>
+            <a:pPr>
+              <a:spcAft>
+                <a:spcPts val="2400"/>
+              </a:spcAft>
+              <a:defRPr sz="1350">
                 <a:solidFill>
                   <a:srgbClr val="14181B"/>
                 </a:solidFill>
@@ -8101,36 +8117,7 @@
               </a:defRPr>
             </a:pPr>
             <a:r>
-              <a:t>พัฒนาแอปพลิเคชันระบบจัดการรถนำเที่ยวไฟฟ้า ที่รองรับทั้งนักท่องเที่ยว คนขับรถ จุดบริการสถานี และผู้บริหาร</a:t>
-            </a:r>
-          </a:p>
-          <a:p>
-            <a:pPr>
-              <a:defRPr sz="1450" b="1">
-                <a:solidFill>
-                  <a:srgbClr val="134074"/>
-                </a:solidFill>
-                <a:latin typeface="Segoe UI"/>
-              </a:defRPr>
-            </a:pPr>
-            <a:r>
-              <a:t>3. บูรณาการข้อมูลการท่องเที่ยวเชิงพื้นที่</a:t>
-            </a:r>
-          </a:p>
-          <a:p>
-            <a:pPr>
-              <a:spcAft>
-                <a:spcPts val="1400"/>
-              </a:spcAft>
-              <a:defRPr sz="1300">
-                <a:solidFill>
-                  <a:srgbClr val="14181B"/>
-                </a:solidFill>
-                <a:latin typeface="Segoe UI"/>
-              </a:defRPr>
-            </a:pPr>
-            <a:r>
-              <a:t>พัฒนารูปแบบการเชื่อมโยงข้อมูลการท่องเที่ยวภายในสวนฯ และจัดทำระบบรายงานสถิติเชิงลึกแบบเวลาจริง (Real-time)</a:t>
+              <a:t>เพื่อพัฒนาแอปพลิเคชันระบบการจัดการรถนำเที่ยวไฟฟ้า ของสวนพฤกษศาสตร์สมเด็จพระนางเจ้าสิริกิติ์ จังหวัดเชียงใหม่</a:t>
             </a:r>
           </a:p>
         </p:txBody>

</xml_diff>

<commit_message>
Remove Tech Stack slide per user request - total 12 slides
</commit_message>
<xml_diff>
--- a/qsbg_smart_tour_presentation.pptx
+++ b/qsbg_smart_tour_presentation.pptx
@@ -17,7 +17,6 @@
     <p:sldId id="265" r:id="rId17"/>
     <p:sldId id="266" r:id="rId18"/>
     <p:sldId id="267" r:id="rId19"/>
-    <p:sldId id="268" r:id="rId20"/>
   </p:sldIdLst>
   <p:sldSz cx="12191695" cy="6858000" type="screen4x3"/>
   <p:notesSz cx="6858000" cy="9144000"/>
@@ -599,7 +598,7 @@
           </a:p>
           <a:p>
             <a:r>
-              <a:t>Tech Stack ที่เราเลือกใช้เป็นเกรด Enterprise: Frontend ใช้ Next.js และ React Native, Backend ใช้ Node.js + Fastify และ Socket.io, ฐานข้อมูลแยก PostgreSQL กับ TimescaleDB และรันบน K8s Cloud ปลอดภัยและรองรับการขยายตัวช่วงเทศกาลได้สบายครับ</a:t>
+              <a:t>แผนงาน 9 เดือน แบ่งเป็น 3 ระยะชัดเจน: Phase 1 สร้างฐานราก Core Foundation, Phase 2 ระบบ Realtime &amp; Mobile App, และ Phase 3 ฟังก์ชันขั้นสูงและการส่งมอบงานสมบูรณ์ มั่นใจได้ว่าส่งมอบตรงเวลาแน่นอนครับ</a:t>
             </a:r>
           </a:p>
         </p:txBody>
@@ -674,7 +673,7 @@
           </a:p>
           <a:p>
             <a:r>
-              <a:t>แผนงาน 9 เดือน แบ่งเป็น 3 ระยะชัดเจน: Phase 1 สร้างฐานราก Core Foundation, Phase 2 ระบบ Realtime &amp; Mobile App, และ Phase 3 ฟังก์ชันขั้นสูงและการส่งมอบงานสมบูรณ์ มั่นใจได้ว่าส่งมอบตรงเวลาแน่นอนครับ</a:t>
+              <a:t>ความคุ้มค่าเกิดขึ้น 4 มิติ: นักท่องเที่ยวสะดวกสบาย, เจ้าหน้าที่ทำงานง่ายขึ้น, ผู้บริหารได้ข้อมูลสถิติตัดสินใจแม่นยำ และด้านสิ่งแวดล้อม การเปลี่ยนมาใช้รถ EV 100% พร้อมจุดชาร์จพลังงานสะอาดช่วยปกป้องธรรมชาติอย่างยั่งยืนครับ</a:t>
             </a:r>
           </a:p>
         </p:txBody>
@@ -744,82 +743,7 @@
           <a:lstStyle/>
           <a:p>
             <a:r>
-              <a:t>สคริปต์พูดหน้าที่ 12 (1.5 นาที):</a:t>
-            </a:r>
-          </a:p>
-          <a:p>
-            <a:r>
-              <a:t>ความคุ้มค่าเกิดขึ้น 4 มิติ: นักท่องเที่ยวสะดวกสบาย, เจ้าหน้าที่ทำงานง่ายขึ้น, ผู้บริหารได้ข้อมูลสถิติตัดสินใจแม่นยำ และด้านสิ่งแวดล้อม การเปลี่ยนมาใช้รถ EV 100% พร้อมจุดชาร์จพลังงานสะอาดช่วยปกป้องธรรมชาติอย่างยั่งยืนครับ</a:t>
-            </a:r>
-          </a:p>
-        </p:txBody>
-      </p:sp>
-      <p:sp>
-        <p:nvSpPr>
-          <p:cNvPr id="4" name="Slide Number Placeholder 3"/>
-          <p:cNvSpPr>
-            <a:spLocks noGrp="1"/>
-          </p:cNvSpPr>
-          <p:nvPr>
-            <p:ph type="sldNum" idx="5" sz="quarter"/>
-          </p:nvPr>
-        </p:nvSpPr>
-        <p:spPr/>
-      </p:sp>
-    </p:spTree>
-  </p:cSld>
-  <p:clrMapOvr>
-    <a:masterClrMapping/>
-  </p:clrMapOvr>
-</p:notes>
-</file>
-
-<file path=ppt/notesSlides/notesSlide13.xml><?xml version="1.0" encoding="utf-8"?>
-<p:notes xmlns:a="http://schemas.openxmlformats.org/drawingml/2006/main" xmlns:p="http://schemas.openxmlformats.org/presentationml/2006/main" xmlns:r="http://schemas.openxmlformats.org/officeDocument/2006/relationships">
-  <p:cSld>
-    <p:spTree>
-      <p:nvGrpSpPr>
-        <p:cNvPr id="1" name=""/>
-        <p:cNvGrpSpPr/>
-        <p:nvPr/>
-      </p:nvGrpSpPr>
-      <p:grpSpPr>
-        <a:xfrm>
-          <a:off x="0" y="0"/>
-          <a:ext cx="0" cy="0"/>
-          <a:chOff x="0" y="0"/>
-          <a:chExt cx="0" cy="0"/>
-        </a:xfrm>
-      </p:grpSpPr>
-      <p:sp>
-        <p:nvSpPr>
-          <p:cNvPr id="2" name="Slide Image Placeholder 1"/>
-          <p:cNvSpPr>
-            <a:spLocks noGrp="1"/>
-          </p:cNvSpPr>
-          <p:nvPr>
-            <p:ph type="sldImg" idx="2"/>
-          </p:nvPr>
-        </p:nvSpPr>
-        <p:spPr/>
-      </p:sp>
-      <p:sp>
-        <p:nvSpPr>
-          <p:cNvPr id="3" name="Notes Placeholder 2"/>
-          <p:cNvSpPr>
-            <a:spLocks noGrp="1"/>
-          </p:cNvSpPr>
-          <p:nvPr>
-            <p:ph type="body" idx="3" sz="quarter"/>
-          </p:nvPr>
-        </p:nvSpPr>
-        <p:spPr/>
-        <p:txBody>
-          <a:bodyPr/>
-          <a:lstStyle/>
-          <a:p>
-            <a:r>
-              <a:t>สคริปต์พูดหน้าที่ 13 (1 นาที):</a:t>
+              <a:t>สคริปต์พูดหน้าที่ 12 (1 นาที):</a:t>
             </a:r>
           </a:p>
           <a:p>
@@ -4877,7 +4801,7 @@
               </a:defRPr>
             </a:pPr>
             <a:r>
-              <a:t>TECHNOLOGY &amp; INFRASTRUCTURE</a:t>
+              <a:t>IMPLEMENTATION ROADMAP</a:t>
             </a:r>
           </a:p>
         </p:txBody>
@@ -4913,7 +4837,7 @@
               </a:defRPr>
             </a:pPr>
             <a:r>
-              <a:t>เทคโนโลยีและโครงสร้างพื้นฐานของระบบ (Tech Stack)</a:t>
+              <a:t>แผนการดำเนินงานและส่งมอบโครงการ (กรอบเวลา 9 เดือน)</a:t>
             </a:r>
           </a:p>
         </p:txBody>
@@ -4949,7 +4873,7 @@
               </a:defRPr>
             </a:pPr>
             <a:r>
-              <a:t>การคัดเลือกสถาปัตยกรรมทางเทคโนโลยีระดับสากลเพื่อความมั่นคงและเสถียรภาพ</a:t>
+              <a:t>การแบ่งระยะการดำเนินงานอย่างเป็นระบบเพื่อการส่งมอบที่ตรงเวลาและมีคุณภาพ</a:t>
             </a:r>
           </a:p>
         </p:txBody>
@@ -4963,7 +4887,7 @@
         <p:spPr>
           <a:xfrm>
             <a:off x="731520" y="1691640"/>
-            <a:ext cx="5120640" cy="2148840"/>
+            <a:ext cx="3328416" cy="4480560"/>
           </a:xfrm>
           <a:prstGeom prst="roundRect">
             <a:avLst/>
@@ -5001,14 +4925,57 @@
       </p:sp>
       <p:sp>
         <p:nvSpPr>
-          <p:cNvPr id="6" name="TextBox 5"/>
+          <p:cNvPr id="6" name="Rectangle 5"/>
+          <p:cNvSpPr/>
+          <p:nvPr/>
+        </p:nvSpPr>
+        <p:spPr>
+          <a:xfrm>
+            <a:off x="731520" y="1691640"/>
+            <a:ext cx="3328416" cy="128016"/>
+          </a:xfrm>
+          <a:prstGeom prst="rect">
+            <a:avLst/>
+          </a:prstGeom>
+          <a:solidFill>
+            <a:srgbClr val="0B2545"/>
+          </a:solidFill>
+          <a:ln>
+            <a:noFill/>
+          </a:ln>
+        </p:spPr>
+        <p:style>
+          <a:lnRef idx="1">
+            <a:schemeClr val="accent1"/>
+          </a:lnRef>
+          <a:fillRef idx="3">
+            <a:schemeClr val="accent1"/>
+          </a:fillRef>
+          <a:effectRef idx="2">
+            <a:schemeClr val="accent1"/>
+          </a:effectRef>
+          <a:fontRef idx="minor">
+            <a:schemeClr val="lt1"/>
+          </a:fontRef>
+        </p:style>
+        <p:txBody>
+          <a:bodyPr rtlCol="0" anchor="ctr"/>
+          <a:lstStyle/>
+          <a:p>
+            <a:pPr algn="ctr"/>
+          </a:p>
+        </p:txBody>
+      </p:sp>
+      <p:sp>
+        <p:nvSpPr>
+          <p:cNvPr id="7" name="TextBox 6"/>
           <p:cNvSpPr txBox="1"/>
           <p:nvPr/>
         </p:nvSpPr>
         <p:spPr>
           <a:xfrm>
-            <a:off x="960120" y="1856232"/>
-            <a:ext cx="4663440" cy="1819656"/>
+            <a:off x="960120" y="1920240"/>
+            <a:ext cx="2871216" cy="4023360"/>
           </a:xfrm>
           <a:prstGeom prst="rect">
             <a:avLst/>
@@ -5023,9 +4990,22 @@
           <a:p>
             <a:pPr>
               <a:spcAft>
-                <a:spcPts val="600"/>
-              </a:spcAft>
-              <a:defRPr sz="1400" b="1">
+                <a:spcPts val="200"/>
+              </a:spcAft>
+              <a:defRPr sz="1200" b="1">
+                <a:solidFill>
+                  <a:srgbClr val="0B2545"/>
+                </a:solidFill>
+                <a:latin typeface="Segoe UI"/>
+              </a:defRPr>
+            </a:pPr>
+            <a:r>
+              <a:t>ระยะที่ 1 (เดือนที่ 1 - 3)</a:t>
+            </a:r>
+          </a:p>
+          <a:p>
+            <a:pPr>
+              <a:defRPr sz="1700" b="1">
                 <a:solidFill>
                   <a:srgbClr val="1B4332"/>
                 </a:solidFill>
@@ -5033,11 +5013,30 @@
               </a:defRPr>
             </a:pPr>
             <a:r>
-              <a:t>FRONTEND &amp; MOBILE PLATFORMS</a:t>
-            </a:r>
-          </a:p>
-          <a:p>
-            <a:pPr>
+              <a:t>Core Foundation</a:t>
+            </a:r>
+          </a:p>
+          <a:p>
+            <a:pPr>
+              <a:spcAft>
+                <a:spcPts val="1200"/>
+              </a:spcAft>
+              <a:defRPr sz="1050">
+                <a:solidFill>
+                  <a:srgbClr val="5A646E"/>
+                </a:solidFill>
+                <a:latin typeface="Segoe UI"/>
+              </a:defRPr>
+            </a:pPr>
+            <a:r>
+              <a:t>รากฐานระบบและการชำระเงิน</a:t>
+            </a:r>
+          </a:p>
+          <a:p>
+            <a:pPr>
+              <a:spcAft>
+                <a:spcPts val="500"/>
+              </a:spcAft>
               <a:defRPr sz="1200">
                 <a:solidFill>
                   <a:srgbClr val="14181B"/>
@@ -5046,29 +5045,101 @@
               </a:defRPr>
             </a:pPr>
             <a:r>
-              <a:t>• Next.js Framework : พัฒนา Web Application และ Admin Dashboard มีประสิทธิภาพสูง รองรับ SEO</a:t>
-            </a:r>
-            <a:br/>
-            <a:r>
-              <a:t>• React Native : พัฒนา Mobile App (iOS / Android) และ Driver App ด้วยโค้ดชุดเดียวกัน</a:t>
-            </a:r>
-            <a:br/>
-            <a:r>
-              <a:t>• Tailwind CSS : ออกแบบหน้าจอให้ทันสมัย รองรับทุกขนาดอุปกรณ์ (Responsive UI)</a:t>
-            </a:r>
-          </a:p>
-        </p:txBody>
-      </p:sp>
-      <p:sp>
-        <p:nvSpPr>
-          <p:cNvPr id="7" name="Rounded Rectangle 6"/>
+              <a:t>• วิเคราะห์และออกแบบ DB Schema และ Architecture</a:t>
+            </a:r>
+          </a:p>
+          <a:p>
+            <a:pPr>
+              <a:spcAft>
+                <a:spcPts val="500"/>
+              </a:spcAft>
+              <a:defRPr sz="1200">
+                <a:solidFill>
+                  <a:srgbClr val="14181B"/>
+                </a:solidFill>
+                <a:latin typeface="Segoe UI"/>
+              </a:defRPr>
+            </a:pPr>
+            <a:r>
+              <a:t>• พัฒนาระบบ Backend API (Ticket, Station, Auth)</a:t>
+            </a:r>
+          </a:p>
+          <a:p>
+            <a:pPr>
+              <a:spcAft>
+                <a:spcPts val="500"/>
+              </a:spcAft>
+              <a:defRPr sz="1200">
+                <a:solidFill>
+                  <a:srgbClr val="14181B"/>
+                </a:solidFill>
+                <a:latin typeface="Segoe UI"/>
+              </a:defRPr>
+            </a:pPr>
+            <a:r>
+              <a:t>• พัฒนา Admin Dashboard จัดการข้อมูลสถานี/รถ</a:t>
+            </a:r>
+          </a:p>
+          <a:p>
+            <a:pPr>
+              <a:spcAft>
+                <a:spcPts val="500"/>
+              </a:spcAft>
+              <a:defRPr sz="1200">
+                <a:solidFill>
+                  <a:srgbClr val="14181B"/>
+                </a:solidFill>
+                <a:latin typeface="Segoe UI"/>
+              </a:defRPr>
+            </a:pPr>
+            <a:r>
+              <a:t>• พัฒนาระบบ Kiosk UI จำหน่ายตั๋วหน้าสถานี</a:t>
+            </a:r>
+          </a:p>
+          <a:p>
+            <a:pPr>
+              <a:spcAft>
+                <a:spcPts val="500"/>
+              </a:spcAft>
+              <a:defRPr sz="1200">
+                <a:solidFill>
+                  <a:srgbClr val="14181B"/>
+                </a:solidFill>
+                <a:latin typeface="Segoe UI"/>
+              </a:defRPr>
+            </a:pPr>
+            <a:r>
+              <a:t>• เชื่อมต่อ Payment Gateway (PromptPay/บัตร/เงินสด)</a:t>
+            </a:r>
+          </a:p>
+          <a:p>
+            <a:pPr>
+              <a:spcAft>
+                <a:spcPts val="500"/>
+              </a:spcAft>
+              <a:defRPr sz="1200">
+                <a:solidFill>
+                  <a:srgbClr val="14181B"/>
+                </a:solidFill>
+                <a:latin typeface="Segoe UI"/>
+              </a:defRPr>
+            </a:pPr>
+            <a:r>
+              <a:t>• พัฒนา Driver App บน Tablet สำหรับคนขับรถ</a:t>
+            </a:r>
+          </a:p>
+        </p:txBody>
+      </p:sp>
+      <p:sp>
+        <p:nvSpPr>
+          <p:cNvPr id="8" name="Rounded Rectangle 7"/>
           <p:cNvSpPr/>
           <p:nvPr/>
         </p:nvSpPr>
         <p:spPr>
           <a:xfrm>
-            <a:off x="6217920" y="1691640"/>
-            <a:ext cx="5120640" cy="2148840"/>
+            <a:off x="4389120" y="1691640"/>
+            <a:ext cx="3328416" cy="4480560"/>
           </a:xfrm>
           <a:prstGeom prst="roundRect">
             <a:avLst/>
@@ -5106,14 +5177,57 @@
       </p:sp>
       <p:sp>
         <p:nvSpPr>
-          <p:cNvPr id="8" name="TextBox 7"/>
+          <p:cNvPr id="9" name="Rectangle 8"/>
+          <p:cNvSpPr/>
+          <p:nvPr/>
+        </p:nvSpPr>
+        <p:spPr>
+          <a:xfrm>
+            <a:off x="4389120" y="1691640"/>
+            <a:ext cx="3328416" cy="128016"/>
+          </a:xfrm>
+          <a:prstGeom prst="rect">
+            <a:avLst/>
+          </a:prstGeom>
+          <a:solidFill>
+            <a:srgbClr val="2D6A4F"/>
+          </a:solidFill>
+          <a:ln>
+            <a:noFill/>
+          </a:ln>
+        </p:spPr>
+        <p:style>
+          <a:lnRef idx="1">
+            <a:schemeClr val="accent1"/>
+          </a:lnRef>
+          <a:fillRef idx="3">
+            <a:schemeClr val="accent1"/>
+          </a:fillRef>
+          <a:effectRef idx="2">
+            <a:schemeClr val="accent1"/>
+          </a:effectRef>
+          <a:fontRef idx="minor">
+            <a:schemeClr val="lt1"/>
+          </a:fontRef>
+        </p:style>
+        <p:txBody>
+          <a:bodyPr rtlCol="0" anchor="ctr"/>
+          <a:lstStyle/>
+          <a:p>
+            <a:pPr algn="ctr"/>
+          </a:p>
+        </p:txBody>
+      </p:sp>
+      <p:sp>
+        <p:nvSpPr>
+          <p:cNvPr id="10" name="TextBox 9"/>
           <p:cNvSpPr txBox="1"/>
           <p:nvPr/>
         </p:nvSpPr>
         <p:spPr>
           <a:xfrm>
-            <a:off x="6446520" y="1856232"/>
-            <a:ext cx="4663440" cy="1819656"/>
+            <a:off x="4617720" y="1920240"/>
+            <a:ext cx="2871216" cy="4023360"/>
           </a:xfrm>
           <a:prstGeom prst="rect">
             <a:avLst/>
@@ -5128,9 +5242,22 @@
           <a:p>
             <a:pPr>
               <a:spcAft>
-                <a:spcPts val="600"/>
-              </a:spcAft>
-              <a:defRPr sz="1400" b="1">
+                <a:spcPts val="200"/>
+              </a:spcAft>
+              <a:defRPr sz="1200" b="1">
+                <a:solidFill>
+                  <a:srgbClr val="2D6A4F"/>
+                </a:solidFill>
+                <a:latin typeface="Segoe UI"/>
+              </a:defRPr>
+            </a:pPr>
+            <a:r>
+              <a:t>ระยะที่ 2 (เดือนที่ 4 - 6)</a:t>
+            </a:r>
+          </a:p>
+          <a:p>
+            <a:pPr>
+              <a:defRPr sz="1700" b="1">
                 <a:solidFill>
                   <a:srgbClr val="1B4332"/>
                 </a:solidFill>
@@ -5138,11 +5265,30 @@
               </a:defRPr>
             </a:pPr>
             <a:r>
-              <a:t>BACKEND &amp; DATA STREAMING</a:t>
-            </a:r>
-          </a:p>
-          <a:p>
-            <a:pPr>
+              <a:t>Realtime &amp; Mobile</a:t>
+            </a:r>
+          </a:p>
+          <a:p>
+            <a:pPr>
+              <a:spcAft>
+                <a:spcPts val="1200"/>
+              </a:spcAft>
+              <a:defRPr sz="1050">
+                <a:solidFill>
+                  <a:srgbClr val="5A646E"/>
+                </a:solidFill>
+                <a:latin typeface="Segoe UI"/>
+              </a:defRPr>
+            </a:pPr>
+            <a:r>
+              <a:t>ระบบเวลาจริงและแอปพลิเคชัน</a:t>
+            </a:r>
+          </a:p>
+          <a:p>
+            <a:pPr>
+              <a:spcAft>
+                <a:spcPts val="500"/>
+              </a:spcAft>
               <a:defRPr sz="1200">
                 <a:solidFill>
                   <a:srgbClr val="14181B"/>
@@ -5151,33 +5297,101 @@
               </a:defRPr>
             </a:pPr>
             <a:r>
-              <a:t>• Node.js &amp; Fastify : เฟรมเวิร์กเซิร์ฟเวอร์ประสิทธิภาพสูง รองรับ Throughput มหาศาล</a:t>
-            </a:r>
-            <a:br/>
-            <a:r>
-              <a:t>• Socket.io Server : รับส่งข้อมูลพิกัด GPS แบบสองทิศทางตามเวลาจริง (Real-time Streaming)</a:t>
-            </a:r>
-            <a:br/>
-            <a:r>
-              <a:t>• Bull Queue &amp; Worker : บริหารคิวงานเบื้องหลัง เช่น การประมวลผลคำสั่งซื้อและการส่งแจ้งเตือน</a:t>
-            </a:r>
-            <a:br/>
-            <a:r>
-              <a:t>• JWT Authentication : ควบคุมการเข้าถึงและรักษาความปลอดภัยของระบบผู้ใช้งาน</a:t>
-            </a:r>
-          </a:p>
-        </p:txBody>
-      </p:sp>
-      <p:sp>
-        <p:nvSpPr>
-          <p:cNvPr id="9" name="Rounded Rectangle 8"/>
+              <a:t>• ติดตั้ง WebSocket Server รองรับ Live Tracking</a:t>
+            </a:r>
+          </a:p>
+          <a:p>
+            <a:pPr>
+              <a:spcAft>
+                <a:spcPts val="500"/>
+              </a:spcAft>
+              <a:defRPr sz="1200">
+                <a:solidFill>
+                  <a:srgbClr val="14181B"/>
+                </a:solidFill>
+                <a:latin typeface="Segoe UI"/>
+              </a:defRPr>
+            </a:pPr>
+            <a:r>
+              <a:t>• พัฒนา Mobile App (iOS / Android) สำหรับนักท่องเที่ยว</a:t>
+            </a:r>
+          </a:p>
+          <a:p>
+            <a:pPr>
+              <a:spcAft>
+                <a:spcPts val="500"/>
+              </a:spcAft>
+              <a:defRPr sz="1200">
+                <a:solidFill>
+                  <a:srgbClr val="14181B"/>
+                </a:solidFill>
+                <a:latin typeface="Segoe UI"/>
+              </a:defRPr>
+            </a:pPr>
+            <a:r>
+              <a:t>• พัฒนาระบบ Queue Management &amp; Smart Balancing</a:t>
+            </a:r>
+          </a:p>
+          <a:p>
+            <a:pPr>
+              <a:spcAft>
+                <a:spcPts val="500"/>
+              </a:spcAft>
+              <a:defRPr sz="1200">
+                <a:solidFill>
+                  <a:srgbClr val="14181B"/>
+                </a:solidFill>
+                <a:latin typeface="Segoe UI"/>
+              </a:defRPr>
+            </a:pPr>
+            <a:r>
+              <a:t>• เชื่อมโยง Geofencing และทดสอบเดินรถ Loop 6 สถานี</a:t>
+            </a:r>
+          </a:p>
+          <a:p>
+            <a:pPr>
+              <a:spcAft>
+                <a:spcPts val="500"/>
+              </a:spcAft>
+              <a:defRPr sz="1200">
+                <a:solidFill>
+                  <a:srgbClr val="14181B"/>
+                </a:solidFill>
+                <a:latin typeface="Segoe UI"/>
+              </a:defRPr>
+            </a:pPr>
+            <a:r>
+              <a:t>• ทดสอบระบบ Check-in สแกน QR Code บนรถจริง</a:t>
+            </a:r>
+          </a:p>
+          <a:p>
+            <a:pPr>
+              <a:spcAft>
+                <a:spcPts val="500"/>
+              </a:spcAft>
+              <a:defRPr sz="1200">
+                <a:solidFill>
+                  <a:srgbClr val="14181B"/>
+                </a:solidFill>
+                <a:latin typeface="Segoe UI"/>
+              </a:defRPr>
+            </a:pPr>
+            <a:r>
+              <a:t>• ทดสอบความเสถียรของสัญญาณสื่อสารในพื้นที่สวนฯ</a:t>
+            </a:r>
+          </a:p>
+        </p:txBody>
+      </p:sp>
+      <p:sp>
+        <p:nvSpPr>
+          <p:cNvPr id="11" name="Rounded Rectangle 10"/>
           <p:cNvSpPr/>
           <p:nvPr/>
         </p:nvSpPr>
         <p:spPr>
           <a:xfrm>
-            <a:off x="731520" y="4023360"/>
-            <a:ext cx="5120640" cy="2148840"/>
+            <a:off x="8046720" y="1691640"/>
+            <a:ext cx="3328416" cy="4480560"/>
           </a:xfrm>
           <a:prstGeom prst="roundRect">
             <a:avLst/>
@@ -5215,85 +5429,23 @@
       </p:sp>
       <p:sp>
         <p:nvSpPr>
-          <p:cNvPr id="10" name="TextBox 9"/>
-          <p:cNvSpPr txBox="1"/>
-          <p:nvPr/>
-        </p:nvSpPr>
-        <p:spPr>
-          <a:xfrm>
-            <a:off x="960120" y="4187952"/>
-            <a:ext cx="4663440" cy="1819656"/>
-          </a:xfrm>
-          <a:prstGeom prst="rect">
-            <a:avLst/>
-          </a:prstGeom>
-          <a:noFill/>
-        </p:spPr>
-        <p:txBody>
-          <a:bodyPr wrap="square">
-            <a:spAutoFit/>
-          </a:bodyPr>
-          <a:lstStyle/>
-          <a:p>
-            <a:pPr>
-              <a:spcAft>
-                <a:spcPts val="600"/>
-              </a:spcAft>
-              <a:defRPr sz="1400" b="1">
-                <a:solidFill>
-                  <a:srgbClr val="1B4332"/>
-                </a:solidFill>
-                <a:latin typeface="Segoe UI"/>
-              </a:defRPr>
-            </a:pPr>
-            <a:r>
-              <a:t>DATABASE &amp; TIME-SERIES MANAGEMENT</a:t>
-            </a:r>
-          </a:p>
-          <a:p>
-            <a:pPr>
-              <a:defRPr sz="1200">
-                <a:solidFill>
-                  <a:srgbClr val="14181B"/>
-                </a:solidFill>
-                <a:latin typeface="Segoe UI"/>
-              </a:defRPr>
-            </a:pPr>
-            <a:r>
-              <a:t>• PostgreSQL : ระบบจัดการฐานข้อมูลหลักสำหรับข้อมูลผู้ใช้ ตั๋ว และการเงิน</a:t>
-            </a:r>
-            <a:br/>
-            <a:r>
-              <a:t>• Redis : In-memory Data Store ทำหน้าที่ Caching และจัดการเซสชันด้วยความเร็วสูง</a:t>
-            </a:r>
-            <a:br/>
-            <a:r>
-              <a:t>• TimescaleDB : ขยายขีดความสามารถสำหรับจัดเก็บพิกัด GPS Time-series นับล้านเรคคอร์ดโดยเฉพาะ</a:t>
-            </a:r>
-          </a:p>
-        </p:txBody>
-      </p:sp>
-      <p:sp>
-        <p:nvSpPr>
-          <p:cNvPr id="11" name="Rounded Rectangle 10"/>
+          <p:cNvPr id="12" name="Rectangle 11"/>
           <p:cNvSpPr/>
           <p:nvPr/>
         </p:nvSpPr>
         <p:spPr>
           <a:xfrm>
-            <a:off x="6217920" y="4023360"/>
-            <a:ext cx="5120640" cy="2148840"/>
-          </a:xfrm>
-          <a:prstGeom prst="roundRect">
+            <a:off x="8046720" y="1691640"/>
+            <a:ext cx="3328416" cy="128016"/>
+          </a:xfrm>
+          <a:prstGeom prst="rect">
             <a:avLst/>
           </a:prstGeom>
           <a:solidFill>
-            <a:srgbClr val="FFFFFF"/>
+            <a:srgbClr val="1B4332"/>
           </a:solidFill>
-          <a:ln w="15240">
-            <a:solidFill>
-              <a:srgbClr val="D2E1DA"/>
-            </a:solidFill>
+          <a:ln>
+            <a:noFill/>
           </a:ln>
         </p:spPr>
         <p:style>
@@ -5320,14 +5472,14 @@
       </p:sp>
       <p:sp>
         <p:nvSpPr>
-          <p:cNvPr id="12" name="TextBox 11"/>
+          <p:cNvPr id="13" name="TextBox 12"/>
           <p:cNvSpPr txBox="1"/>
           <p:nvPr/>
         </p:nvSpPr>
         <p:spPr>
           <a:xfrm>
-            <a:off x="6446520" y="4187952"/>
-            <a:ext cx="4663440" cy="1819656"/>
+            <a:off x="8275320" y="1920240"/>
+            <a:ext cx="2871216" cy="4023360"/>
           </a:xfrm>
           <a:prstGeom prst="rect">
             <a:avLst/>
@@ -5342,9 +5494,9 @@
           <a:p>
             <a:pPr>
               <a:spcAft>
-                <a:spcPts val="600"/>
-              </a:spcAft>
-              <a:defRPr sz="1400" b="1">
+                <a:spcPts val="200"/>
+              </a:spcAft>
+              <a:defRPr sz="1200" b="1">
                 <a:solidFill>
                   <a:srgbClr val="1B4332"/>
                 </a:solidFill>
@@ -5352,11 +5504,43 @@
               </a:defRPr>
             </a:pPr>
             <a:r>
-              <a:t>INFRASTRUCTURE &amp; DEVOPS PIPELINE</a:t>
-            </a:r>
-          </a:p>
-          <a:p>
-            <a:pPr>
+              <a:t>ระยะที่ 3 (เดือนที่ 7 - 9)</a:t>
+            </a:r>
+          </a:p>
+          <a:p>
+            <a:pPr>
+              <a:defRPr sz="1700" b="1">
+                <a:solidFill>
+                  <a:srgbClr val="1B4332"/>
+                </a:solidFill>
+                <a:latin typeface="Segoe UI"/>
+              </a:defRPr>
+            </a:pPr>
+            <a:r>
+              <a:t>Advanced Features &amp; Rollout</a:t>
+            </a:r>
+          </a:p>
+          <a:p>
+            <a:pPr>
+              <a:spcAft>
+                <a:spcPts val="1200"/>
+              </a:spcAft>
+              <a:defRPr sz="1050">
+                <a:solidFill>
+                  <a:srgbClr val="5A646E"/>
+                </a:solidFill>
+                <a:latin typeface="Segoe UI"/>
+              </a:defRPr>
+            </a:pPr>
+            <a:r>
+              <a:t>ฟังก์ชันขั้นสูงและการส่งมอบ</a:t>
+            </a:r>
+          </a:p>
+          <a:p>
+            <a:pPr>
+              <a:spcAft>
+                <a:spcPts val="500"/>
+              </a:spcAft>
               <a:defRPr sz="1200">
                 <a:solidFill>
                   <a:srgbClr val="14181B"/>
@@ -5365,15 +5549,87 @@
               </a:defRPr>
             </a:pPr>
             <a:r>
-              <a:t>• Docker &amp; Kubernetes (K8s) : เทคโนโลยี Containerization รองรับการขยายตัวอัตโนมัติ</a:t>
-            </a:r>
-            <a:br/>
-            <a:r>
-              <a:t>• Enterprise Cloud Hosting : ติดตั้งบนคลาวด์มาตรฐานความปลอดภัยสูง การันตี Uptime 99.9%</a:t>
-            </a:r>
-            <a:br/>
-            <a:r>
-              <a:t>• GitHub Actions CI/CD : ระบบทดสอบความปลอดภัยและการปรับปรุงโปรแกรมแบบอัตโนมัติ</a:t>
+              <a:t>• พัฒนาระบบ Push Notification (App / LINE / SMS)</a:t>
+            </a:r>
+          </a:p>
+          <a:p>
+            <a:pPr>
+              <a:spcAft>
+                <a:spcPts val="500"/>
+              </a:spcAft>
+              <a:defRPr sz="1200">
+                <a:solidFill>
+                  <a:srgbClr val="14181B"/>
+                </a:solidFill>
+                <a:latin typeface="Segoe UI"/>
+              </a:defRPr>
+            </a:pPr>
+            <a:r>
+              <a:t>• พัฒนาระบบ Real-time Analytics Dashboard เชิงพื้นที่</a:t>
+            </a:r>
+          </a:p>
+          <a:p>
+            <a:pPr>
+              <a:spcAft>
+                <a:spcPts val="500"/>
+              </a:spcAft>
+              <a:defRPr sz="1200">
+                <a:solidFill>
+                  <a:srgbClr val="14181B"/>
+                </a:solidFill>
+                <a:latin typeface="Segoe UI"/>
+              </a:defRPr>
+            </a:pPr>
+            <a:r>
+              <a:t>• เปิดใช้งานระบบจองตั๋วออนไลน์ล่วงหน้า (Online Booking)</a:t>
+            </a:r>
+          </a:p>
+          <a:p>
+            <a:pPr>
+              <a:spcAft>
+                <a:spcPts val="500"/>
+              </a:spcAft>
+              <a:defRPr sz="1200">
+                <a:solidFill>
+                  <a:srgbClr val="14181B"/>
+                </a:solidFill>
+                <a:latin typeface="Segoe UI"/>
+              </a:defRPr>
+            </a:pPr>
+            <a:r>
+              <a:t>• จัดทำคู่มือการใช้งานระบบสำหรับผู้ใช้ทุกระดับ</a:t>
+            </a:r>
+          </a:p>
+          <a:p>
+            <a:pPr>
+              <a:spcAft>
+                <a:spcPts val="500"/>
+              </a:spcAft>
+              <a:defRPr sz="1200">
+                <a:solidFill>
+                  <a:srgbClr val="14181B"/>
+                </a:solidFill>
+                <a:latin typeface="Segoe UI"/>
+              </a:defRPr>
+            </a:pPr>
+            <a:r>
+              <a:t>• จัดฝึกอบรมเชิงปฏิบัติการแก่เจ้าหน้าที่และพนักงานขับรถ</a:t>
+            </a:r>
+          </a:p>
+          <a:p>
+            <a:pPr>
+              <a:spcAft>
+                <a:spcPts val="500"/>
+              </a:spcAft>
+              <a:defRPr sz="1200">
+                <a:solidFill>
+                  <a:srgbClr val="14181B"/>
+                </a:solidFill>
+                <a:latin typeface="Segoe UI"/>
+              </a:defRPr>
+            </a:pPr>
+            <a:r>
+              <a:t>• ทดสอบระบบเสร็จสมบูรณ์ และส่งมอบงานสมบูรณ์</a:t>
             </a:r>
           </a:p>
         </p:txBody>
@@ -5435,896 +5691,6 @@
               </a:defRPr>
             </a:pPr>
             <a:r>
-              <a:t>IMPLEMENTATION ROADMAP</a:t>
-            </a:r>
-          </a:p>
-        </p:txBody>
-      </p:sp>
-      <p:sp>
-        <p:nvSpPr>
-          <p:cNvPr id="3" name="TextBox 2"/>
-          <p:cNvSpPr txBox="1"/>
-          <p:nvPr/>
-        </p:nvSpPr>
-        <p:spPr>
-          <a:xfrm>
-            <a:off x="731520" y="658368"/>
-            <a:ext cx="10698480" cy="594360"/>
-          </a:xfrm>
-          <a:prstGeom prst="rect">
-            <a:avLst/>
-          </a:prstGeom>
-          <a:noFill/>
-        </p:spPr>
-        <p:txBody>
-          <a:bodyPr wrap="square" lIns="0" tIns="0" rIns="0" bIns="0">
-            <a:spAutoFit/>
-          </a:bodyPr>
-          <a:lstStyle/>
-          <a:p>
-            <a:pPr>
-              <a:defRPr sz="2600" b="1">
-                <a:solidFill>
-                  <a:srgbClr val="1B4332"/>
-                </a:solidFill>
-                <a:latin typeface="Segoe UI"/>
-              </a:defRPr>
-            </a:pPr>
-            <a:r>
-              <a:t>แผนการดำเนินงานและส่งมอบโครงการ (กรอบเวลา 9 เดือน)</a:t>
-            </a:r>
-          </a:p>
-        </p:txBody>
-      </p:sp>
-      <p:sp>
-        <p:nvSpPr>
-          <p:cNvPr id="4" name="TextBox 3"/>
-          <p:cNvSpPr txBox="1"/>
-          <p:nvPr/>
-        </p:nvSpPr>
-        <p:spPr>
-          <a:xfrm>
-            <a:off x="731520" y="1234440"/>
-            <a:ext cx="10698480" cy="365760"/>
-          </a:xfrm>
-          <a:prstGeom prst="rect">
-            <a:avLst/>
-          </a:prstGeom>
-          <a:noFill/>
-        </p:spPr>
-        <p:txBody>
-          <a:bodyPr wrap="square" lIns="0" tIns="0" rIns="0" bIns="0">
-            <a:spAutoFit/>
-          </a:bodyPr>
-          <a:lstStyle/>
-          <a:p>
-            <a:pPr>
-              <a:defRPr sz="1350">
-                <a:solidFill>
-                  <a:srgbClr val="5A646E"/>
-                </a:solidFill>
-                <a:latin typeface="Segoe UI"/>
-              </a:defRPr>
-            </a:pPr>
-            <a:r>
-              <a:t>การแบ่งระยะการดำเนินงานอย่างเป็นระบบเพื่อการส่งมอบที่ตรงเวลาและมีคุณภาพ</a:t>
-            </a:r>
-          </a:p>
-        </p:txBody>
-      </p:sp>
-      <p:sp>
-        <p:nvSpPr>
-          <p:cNvPr id="5" name="Rounded Rectangle 4"/>
-          <p:cNvSpPr/>
-          <p:nvPr/>
-        </p:nvSpPr>
-        <p:spPr>
-          <a:xfrm>
-            <a:off x="731520" y="1691640"/>
-            <a:ext cx="3328416" cy="4480560"/>
-          </a:xfrm>
-          <a:prstGeom prst="roundRect">
-            <a:avLst/>
-          </a:prstGeom>
-          <a:solidFill>
-            <a:srgbClr val="FFFFFF"/>
-          </a:solidFill>
-          <a:ln w="15240">
-            <a:solidFill>
-              <a:srgbClr val="D2E1DA"/>
-            </a:solidFill>
-          </a:ln>
-        </p:spPr>
-        <p:style>
-          <a:lnRef idx="1">
-            <a:schemeClr val="accent1"/>
-          </a:lnRef>
-          <a:fillRef idx="3">
-            <a:schemeClr val="accent1"/>
-          </a:fillRef>
-          <a:effectRef idx="2">
-            <a:schemeClr val="accent1"/>
-          </a:effectRef>
-          <a:fontRef idx="minor">
-            <a:schemeClr val="lt1"/>
-          </a:fontRef>
-        </p:style>
-        <p:txBody>
-          <a:bodyPr rtlCol="0" anchor="ctr"/>
-          <a:lstStyle/>
-          <a:p>
-            <a:pPr algn="ctr"/>
-          </a:p>
-        </p:txBody>
-      </p:sp>
-      <p:sp>
-        <p:nvSpPr>
-          <p:cNvPr id="6" name="Rectangle 5"/>
-          <p:cNvSpPr/>
-          <p:nvPr/>
-        </p:nvSpPr>
-        <p:spPr>
-          <a:xfrm>
-            <a:off x="731520" y="1691640"/>
-            <a:ext cx="3328416" cy="128016"/>
-          </a:xfrm>
-          <a:prstGeom prst="rect">
-            <a:avLst/>
-          </a:prstGeom>
-          <a:solidFill>
-            <a:srgbClr val="0B2545"/>
-          </a:solidFill>
-          <a:ln>
-            <a:noFill/>
-          </a:ln>
-        </p:spPr>
-        <p:style>
-          <a:lnRef idx="1">
-            <a:schemeClr val="accent1"/>
-          </a:lnRef>
-          <a:fillRef idx="3">
-            <a:schemeClr val="accent1"/>
-          </a:fillRef>
-          <a:effectRef idx="2">
-            <a:schemeClr val="accent1"/>
-          </a:effectRef>
-          <a:fontRef idx="minor">
-            <a:schemeClr val="lt1"/>
-          </a:fontRef>
-        </p:style>
-        <p:txBody>
-          <a:bodyPr rtlCol="0" anchor="ctr"/>
-          <a:lstStyle/>
-          <a:p>
-            <a:pPr algn="ctr"/>
-          </a:p>
-        </p:txBody>
-      </p:sp>
-      <p:sp>
-        <p:nvSpPr>
-          <p:cNvPr id="7" name="TextBox 6"/>
-          <p:cNvSpPr txBox="1"/>
-          <p:nvPr/>
-        </p:nvSpPr>
-        <p:spPr>
-          <a:xfrm>
-            <a:off x="960120" y="1920240"/>
-            <a:ext cx="2871216" cy="4023360"/>
-          </a:xfrm>
-          <a:prstGeom prst="rect">
-            <a:avLst/>
-          </a:prstGeom>
-          <a:noFill/>
-        </p:spPr>
-        <p:txBody>
-          <a:bodyPr wrap="square">
-            <a:spAutoFit/>
-          </a:bodyPr>
-          <a:lstStyle/>
-          <a:p>
-            <a:pPr>
-              <a:spcAft>
-                <a:spcPts val="200"/>
-              </a:spcAft>
-              <a:defRPr sz="1200" b="1">
-                <a:solidFill>
-                  <a:srgbClr val="0B2545"/>
-                </a:solidFill>
-                <a:latin typeface="Segoe UI"/>
-              </a:defRPr>
-            </a:pPr>
-            <a:r>
-              <a:t>ระยะที่ 1 (เดือนที่ 1 - 3)</a:t>
-            </a:r>
-          </a:p>
-          <a:p>
-            <a:pPr>
-              <a:defRPr sz="1700" b="1">
-                <a:solidFill>
-                  <a:srgbClr val="1B4332"/>
-                </a:solidFill>
-                <a:latin typeface="Segoe UI"/>
-              </a:defRPr>
-            </a:pPr>
-            <a:r>
-              <a:t>Core Foundation</a:t>
-            </a:r>
-          </a:p>
-          <a:p>
-            <a:pPr>
-              <a:spcAft>
-                <a:spcPts val="1200"/>
-              </a:spcAft>
-              <a:defRPr sz="1050">
-                <a:solidFill>
-                  <a:srgbClr val="5A646E"/>
-                </a:solidFill>
-                <a:latin typeface="Segoe UI"/>
-              </a:defRPr>
-            </a:pPr>
-            <a:r>
-              <a:t>รากฐานระบบและการชำระเงิน</a:t>
-            </a:r>
-          </a:p>
-          <a:p>
-            <a:pPr>
-              <a:spcAft>
-                <a:spcPts val="500"/>
-              </a:spcAft>
-              <a:defRPr sz="1200">
-                <a:solidFill>
-                  <a:srgbClr val="14181B"/>
-                </a:solidFill>
-                <a:latin typeface="Segoe UI"/>
-              </a:defRPr>
-            </a:pPr>
-            <a:r>
-              <a:t>• วิเคราะห์และออกแบบ DB Schema และ Architecture</a:t>
-            </a:r>
-          </a:p>
-          <a:p>
-            <a:pPr>
-              <a:spcAft>
-                <a:spcPts val="500"/>
-              </a:spcAft>
-              <a:defRPr sz="1200">
-                <a:solidFill>
-                  <a:srgbClr val="14181B"/>
-                </a:solidFill>
-                <a:latin typeface="Segoe UI"/>
-              </a:defRPr>
-            </a:pPr>
-            <a:r>
-              <a:t>• พัฒนาระบบ Backend API (Ticket, Station, Auth)</a:t>
-            </a:r>
-          </a:p>
-          <a:p>
-            <a:pPr>
-              <a:spcAft>
-                <a:spcPts val="500"/>
-              </a:spcAft>
-              <a:defRPr sz="1200">
-                <a:solidFill>
-                  <a:srgbClr val="14181B"/>
-                </a:solidFill>
-                <a:latin typeface="Segoe UI"/>
-              </a:defRPr>
-            </a:pPr>
-            <a:r>
-              <a:t>• พัฒนา Admin Dashboard จัดการข้อมูลสถานี/รถ</a:t>
-            </a:r>
-          </a:p>
-          <a:p>
-            <a:pPr>
-              <a:spcAft>
-                <a:spcPts val="500"/>
-              </a:spcAft>
-              <a:defRPr sz="1200">
-                <a:solidFill>
-                  <a:srgbClr val="14181B"/>
-                </a:solidFill>
-                <a:latin typeface="Segoe UI"/>
-              </a:defRPr>
-            </a:pPr>
-            <a:r>
-              <a:t>• พัฒนาระบบ Kiosk UI จำหน่ายตั๋วหน้าสถานี</a:t>
-            </a:r>
-          </a:p>
-          <a:p>
-            <a:pPr>
-              <a:spcAft>
-                <a:spcPts val="500"/>
-              </a:spcAft>
-              <a:defRPr sz="1200">
-                <a:solidFill>
-                  <a:srgbClr val="14181B"/>
-                </a:solidFill>
-                <a:latin typeface="Segoe UI"/>
-              </a:defRPr>
-            </a:pPr>
-            <a:r>
-              <a:t>• เชื่อมต่อ Payment Gateway (PromptPay/บัตร/เงินสด)</a:t>
-            </a:r>
-          </a:p>
-          <a:p>
-            <a:pPr>
-              <a:spcAft>
-                <a:spcPts val="500"/>
-              </a:spcAft>
-              <a:defRPr sz="1200">
-                <a:solidFill>
-                  <a:srgbClr val="14181B"/>
-                </a:solidFill>
-                <a:latin typeface="Segoe UI"/>
-              </a:defRPr>
-            </a:pPr>
-            <a:r>
-              <a:t>• พัฒนา Driver App บน Tablet สำหรับคนขับรถ</a:t>
-            </a:r>
-          </a:p>
-        </p:txBody>
-      </p:sp>
-      <p:sp>
-        <p:nvSpPr>
-          <p:cNvPr id="8" name="Rounded Rectangle 7"/>
-          <p:cNvSpPr/>
-          <p:nvPr/>
-        </p:nvSpPr>
-        <p:spPr>
-          <a:xfrm>
-            <a:off x="4389120" y="1691640"/>
-            <a:ext cx="3328416" cy="4480560"/>
-          </a:xfrm>
-          <a:prstGeom prst="roundRect">
-            <a:avLst/>
-          </a:prstGeom>
-          <a:solidFill>
-            <a:srgbClr val="FFFFFF"/>
-          </a:solidFill>
-          <a:ln w="15240">
-            <a:solidFill>
-              <a:srgbClr val="D2E1DA"/>
-            </a:solidFill>
-          </a:ln>
-        </p:spPr>
-        <p:style>
-          <a:lnRef idx="1">
-            <a:schemeClr val="accent1"/>
-          </a:lnRef>
-          <a:fillRef idx="3">
-            <a:schemeClr val="accent1"/>
-          </a:fillRef>
-          <a:effectRef idx="2">
-            <a:schemeClr val="accent1"/>
-          </a:effectRef>
-          <a:fontRef idx="minor">
-            <a:schemeClr val="lt1"/>
-          </a:fontRef>
-        </p:style>
-        <p:txBody>
-          <a:bodyPr rtlCol="0" anchor="ctr"/>
-          <a:lstStyle/>
-          <a:p>
-            <a:pPr algn="ctr"/>
-          </a:p>
-        </p:txBody>
-      </p:sp>
-      <p:sp>
-        <p:nvSpPr>
-          <p:cNvPr id="9" name="Rectangle 8"/>
-          <p:cNvSpPr/>
-          <p:nvPr/>
-        </p:nvSpPr>
-        <p:spPr>
-          <a:xfrm>
-            <a:off x="4389120" y="1691640"/>
-            <a:ext cx="3328416" cy="128016"/>
-          </a:xfrm>
-          <a:prstGeom prst="rect">
-            <a:avLst/>
-          </a:prstGeom>
-          <a:solidFill>
-            <a:srgbClr val="2D6A4F"/>
-          </a:solidFill>
-          <a:ln>
-            <a:noFill/>
-          </a:ln>
-        </p:spPr>
-        <p:style>
-          <a:lnRef idx="1">
-            <a:schemeClr val="accent1"/>
-          </a:lnRef>
-          <a:fillRef idx="3">
-            <a:schemeClr val="accent1"/>
-          </a:fillRef>
-          <a:effectRef idx="2">
-            <a:schemeClr val="accent1"/>
-          </a:effectRef>
-          <a:fontRef idx="minor">
-            <a:schemeClr val="lt1"/>
-          </a:fontRef>
-        </p:style>
-        <p:txBody>
-          <a:bodyPr rtlCol="0" anchor="ctr"/>
-          <a:lstStyle/>
-          <a:p>
-            <a:pPr algn="ctr"/>
-          </a:p>
-        </p:txBody>
-      </p:sp>
-      <p:sp>
-        <p:nvSpPr>
-          <p:cNvPr id="10" name="TextBox 9"/>
-          <p:cNvSpPr txBox="1"/>
-          <p:nvPr/>
-        </p:nvSpPr>
-        <p:spPr>
-          <a:xfrm>
-            <a:off x="4617720" y="1920240"/>
-            <a:ext cx="2871216" cy="4023360"/>
-          </a:xfrm>
-          <a:prstGeom prst="rect">
-            <a:avLst/>
-          </a:prstGeom>
-          <a:noFill/>
-        </p:spPr>
-        <p:txBody>
-          <a:bodyPr wrap="square">
-            <a:spAutoFit/>
-          </a:bodyPr>
-          <a:lstStyle/>
-          <a:p>
-            <a:pPr>
-              <a:spcAft>
-                <a:spcPts val="200"/>
-              </a:spcAft>
-              <a:defRPr sz="1200" b="1">
-                <a:solidFill>
-                  <a:srgbClr val="2D6A4F"/>
-                </a:solidFill>
-                <a:latin typeface="Segoe UI"/>
-              </a:defRPr>
-            </a:pPr>
-            <a:r>
-              <a:t>ระยะที่ 2 (เดือนที่ 4 - 6)</a:t>
-            </a:r>
-          </a:p>
-          <a:p>
-            <a:pPr>
-              <a:defRPr sz="1700" b="1">
-                <a:solidFill>
-                  <a:srgbClr val="1B4332"/>
-                </a:solidFill>
-                <a:latin typeface="Segoe UI"/>
-              </a:defRPr>
-            </a:pPr>
-            <a:r>
-              <a:t>Realtime &amp; Mobile</a:t>
-            </a:r>
-          </a:p>
-          <a:p>
-            <a:pPr>
-              <a:spcAft>
-                <a:spcPts val="1200"/>
-              </a:spcAft>
-              <a:defRPr sz="1050">
-                <a:solidFill>
-                  <a:srgbClr val="5A646E"/>
-                </a:solidFill>
-                <a:latin typeface="Segoe UI"/>
-              </a:defRPr>
-            </a:pPr>
-            <a:r>
-              <a:t>ระบบเวลาจริงและแอปพลิเคชัน</a:t>
-            </a:r>
-          </a:p>
-          <a:p>
-            <a:pPr>
-              <a:spcAft>
-                <a:spcPts val="500"/>
-              </a:spcAft>
-              <a:defRPr sz="1200">
-                <a:solidFill>
-                  <a:srgbClr val="14181B"/>
-                </a:solidFill>
-                <a:latin typeface="Segoe UI"/>
-              </a:defRPr>
-            </a:pPr>
-            <a:r>
-              <a:t>• ติดตั้ง WebSocket Server รองรับ Live Tracking</a:t>
-            </a:r>
-          </a:p>
-          <a:p>
-            <a:pPr>
-              <a:spcAft>
-                <a:spcPts val="500"/>
-              </a:spcAft>
-              <a:defRPr sz="1200">
-                <a:solidFill>
-                  <a:srgbClr val="14181B"/>
-                </a:solidFill>
-                <a:latin typeface="Segoe UI"/>
-              </a:defRPr>
-            </a:pPr>
-            <a:r>
-              <a:t>• พัฒนา Mobile App (iOS / Android) สำหรับนักท่องเที่ยว</a:t>
-            </a:r>
-          </a:p>
-          <a:p>
-            <a:pPr>
-              <a:spcAft>
-                <a:spcPts val="500"/>
-              </a:spcAft>
-              <a:defRPr sz="1200">
-                <a:solidFill>
-                  <a:srgbClr val="14181B"/>
-                </a:solidFill>
-                <a:latin typeface="Segoe UI"/>
-              </a:defRPr>
-            </a:pPr>
-            <a:r>
-              <a:t>• พัฒนาระบบ Queue Management &amp; Smart Balancing</a:t>
-            </a:r>
-          </a:p>
-          <a:p>
-            <a:pPr>
-              <a:spcAft>
-                <a:spcPts val="500"/>
-              </a:spcAft>
-              <a:defRPr sz="1200">
-                <a:solidFill>
-                  <a:srgbClr val="14181B"/>
-                </a:solidFill>
-                <a:latin typeface="Segoe UI"/>
-              </a:defRPr>
-            </a:pPr>
-            <a:r>
-              <a:t>• เชื่อมโยง Geofencing และทดสอบเดินรถ Loop 6 สถานี</a:t>
-            </a:r>
-          </a:p>
-          <a:p>
-            <a:pPr>
-              <a:spcAft>
-                <a:spcPts val="500"/>
-              </a:spcAft>
-              <a:defRPr sz="1200">
-                <a:solidFill>
-                  <a:srgbClr val="14181B"/>
-                </a:solidFill>
-                <a:latin typeface="Segoe UI"/>
-              </a:defRPr>
-            </a:pPr>
-            <a:r>
-              <a:t>• ทดสอบระบบ Check-in สแกน QR Code บนรถจริง</a:t>
-            </a:r>
-          </a:p>
-          <a:p>
-            <a:pPr>
-              <a:spcAft>
-                <a:spcPts val="500"/>
-              </a:spcAft>
-              <a:defRPr sz="1200">
-                <a:solidFill>
-                  <a:srgbClr val="14181B"/>
-                </a:solidFill>
-                <a:latin typeface="Segoe UI"/>
-              </a:defRPr>
-            </a:pPr>
-            <a:r>
-              <a:t>• ทดสอบความเสถียรของสัญญาณสื่อสารในพื้นที่สวนฯ</a:t>
-            </a:r>
-          </a:p>
-        </p:txBody>
-      </p:sp>
-      <p:sp>
-        <p:nvSpPr>
-          <p:cNvPr id="11" name="Rounded Rectangle 10"/>
-          <p:cNvSpPr/>
-          <p:nvPr/>
-        </p:nvSpPr>
-        <p:spPr>
-          <a:xfrm>
-            <a:off x="8046720" y="1691640"/>
-            <a:ext cx="3328416" cy="4480560"/>
-          </a:xfrm>
-          <a:prstGeom prst="roundRect">
-            <a:avLst/>
-          </a:prstGeom>
-          <a:solidFill>
-            <a:srgbClr val="FFFFFF"/>
-          </a:solidFill>
-          <a:ln w="15240">
-            <a:solidFill>
-              <a:srgbClr val="D2E1DA"/>
-            </a:solidFill>
-          </a:ln>
-        </p:spPr>
-        <p:style>
-          <a:lnRef idx="1">
-            <a:schemeClr val="accent1"/>
-          </a:lnRef>
-          <a:fillRef idx="3">
-            <a:schemeClr val="accent1"/>
-          </a:fillRef>
-          <a:effectRef idx="2">
-            <a:schemeClr val="accent1"/>
-          </a:effectRef>
-          <a:fontRef idx="minor">
-            <a:schemeClr val="lt1"/>
-          </a:fontRef>
-        </p:style>
-        <p:txBody>
-          <a:bodyPr rtlCol="0" anchor="ctr"/>
-          <a:lstStyle/>
-          <a:p>
-            <a:pPr algn="ctr"/>
-          </a:p>
-        </p:txBody>
-      </p:sp>
-      <p:sp>
-        <p:nvSpPr>
-          <p:cNvPr id="12" name="Rectangle 11"/>
-          <p:cNvSpPr/>
-          <p:nvPr/>
-        </p:nvSpPr>
-        <p:spPr>
-          <a:xfrm>
-            <a:off x="8046720" y="1691640"/>
-            <a:ext cx="3328416" cy="128016"/>
-          </a:xfrm>
-          <a:prstGeom prst="rect">
-            <a:avLst/>
-          </a:prstGeom>
-          <a:solidFill>
-            <a:srgbClr val="1B4332"/>
-          </a:solidFill>
-          <a:ln>
-            <a:noFill/>
-          </a:ln>
-        </p:spPr>
-        <p:style>
-          <a:lnRef idx="1">
-            <a:schemeClr val="accent1"/>
-          </a:lnRef>
-          <a:fillRef idx="3">
-            <a:schemeClr val="accent1"/>
-          </a:fillRef>
-          <a:effectRef idx="2">
-            <a:schemeClr val="accent1"/>
-          </a:effectRef>
-          <a:fontRef idx="minor">
-            <a:schemeClr val="lt1"/>
-          </a:fontRef>
-        </p:style>
-        <p:txBody>
-          <a:bodyPr rtlCol="0" anchor="ctr"/>
-          <a:lstStyle/>
-          <a:p>
-            <a:pPr algn="ctr"/>
-          </a:p>
-        </p:txBody>
-      </p:sp>
-      <p:sp>
-        <p:nvSpPr>
-          <p:cNvPr id="13" name="TextBox 12"/>
-          <p:cNvSpPr txBox="1"/>
-          <p:nvPr/>
-        </p:nvSpPr>
-        <p:spPr>
-          <a:xfrm>
-            <a:off x="8275320" y="1920240"/>
-            <a:ext cx="2871216" cy="4023360"/>
-          </a:xfrm>
-          <a:prstGeom prst="rect">
-            <a:avLst/>
-          </a:prstGeom>
-          <a:noFill/>
-        </p:spPr>
-        <p:txBody>
-          <a:bodyPr wrap="square">
-            <a:spAutoFit/>
-          </a:bodyPr>
-          <a:lstStyle/>
-          <a:p>
-            <a:pPr>
-              <a:spcAft>
-                <a:spcPts val="200"/>
-              </a:spcAft>
-              <a:defRPr sz="1200" b="1">
-                <a:solidFill>
-                  <a:srgbClr val="1B4332"/>
-                </a:solidFill>
-                <a:latin typeface="Segoe UI"/>
-              </a:defRPr>
-            </a:pPr>
-            <a:r>
-              <a:t>ระยะที่ 3 (เดือนที่ 7 - 9)</a:t>
-            </a:r>
-          </a:p>
-          <a:p>
-            <a:pPr>
-              <a:defRPr sz="1700" b="1">
-                <a:solidFill>
-                  <a:srgbClr val="1B4332"/>
-                </a:solidFill>
-                <a:latin typeface="Segoe UI"/>
-              </a:defRPr>
-            </a:pPr>
-            <a:r>
-              <a:t>Advanced Features &amp; Rollout</a:t>
-            </a:r>
-          </a:p>
-          <a:p>
-            <a:pPr>
-              <a:spcAft>
-                <a:spcPts val="1200"/>
-              </a:spcAft>
-              <a:defRPr sz="1050">
-                <a:solidFill>
-                  <a:srgbClr val="5A646E"/>
-                </a:solidFill>
-                <a:latin typeface="Segoe UI"/>
-              </a:defRPr>
-            </a:pPr>
-            <a:r>
-              <a:t>ฟังก์ชันขั้นสูงและการส่งมอบ</a:t>
-            </a:r>
-          </a:p>
-          <a:p>
-            <a:pPr>
-              <a:spcAft>
-                <a:spcPts val="500"/>
-              </a:spcAft>
-              <a:defRPr sz="1200">
-                <a:solidFill>
-                  <a:srgbClr val="14181B"/>
-                </a:solidFill>
-                <a:latin typeface="Segoe UI"/>
-              </a:defRPr>
-            </a:pPr>
-            <a:r>
-              <a:t>• พัฒนาระบบ Push Notification (App / LINE / SMS)</a:t>
-            </a:r>
-          </a:p>
-          <a:p>
-            <a:pPr>
-              <a:spcAft>
-                <a:spcPts val="500"/>
-              </a:spcAft>
-              <a:defRPr sz="1200">
-                <a:solidFill>
-                  <a:srgbClr val="14181B"/>
-                </a:solidFill>
-                <a:latin typeface="Segoe UI"/>
-              </a:defRPr>
-            </a:pPr>
-            <a:r>
-              <a:t>• พัฒนาระบบ Real-time Analytics Dashboard เชิงพื้นที่</a:t>
-            </a:r>
-          </a:p>
-          <a:p>
-            <a:pPr>
-              <a:spcAft>
-                <a:spcPts val="500"/>
-              </a:spcAft>
-              <a:defRPr sz="1200">
-                <a:solidFill>
-                  <a:srgbClr val="14181B"/>
-                </a:solidFill>
-                <a:latin typeface="Segoe UI"/>
-              </a:defRPr>
-            </a:pPr>
-            <a:r>
-              <a:t>• เปิดใช้งานระบบจองตั๋วออนไลน์ล่วงหน้า (Online Booking)</a:t>
-            </a:r>
-          </a:p>
-          <a:p>
-            <a:pPr>
-              <a:spcAft>
-                <a:spcPts val="500"/>
-              </a:spcAft>
-              <a:defRPr sz="1200">
-                <a:solidFill>
-                  <a:srgbClr val="14181B"/>
-                </a:solidFill>
-                <a:latin typeface="Segoe UI"/>
-              </a:defRPr>
-            </a:pPr>
-            <a:r>
-              <a:t>• จัดทำคู่มือการใช้งานระบบสำหรับผู้ใช้ทุกระดับ</a:t>
-            </a:r>
-          </a:p>
-          <a:p>
-            <a:pPr>
-              <a:spcAft>
-                <a:spcPts val="500"/>
-              </a:spcAft>
-              <a:defRPr sz="1200">
-                <a:solidFill>
-                  <a:srgbClr val="14181B"/>
-                </a:solidFill>
-                <a:latin typeface="Segoe UI"/>
-              </a:defRPr>
-            </a:pPr>
-            <a:r>
-              <a:t>• จัดฝึกอบรมเชิงปฏิบัติการแก่เจ้าหน้าที่และพนักงานขับรถ</a:t>
-            </a:r>
-          </a:p>
-          <a:p>
-            <a:pPr>
-              <a:spcAft>
-                <a:spcPts val="500"/>
-              </a:spcAft>
-              <a:defRPr sz="1200">
-                <a:solidFill>
-                  <a:srgbClr val="14181B"/>
-                </a:solidFill>
-                <a:latin typeface="Segoe UI"/>
-              </a:defRPr>
-            </a:pPr>
-            <a:r>
-              <a:t>• ทดสอบระบบเสร็จสมบูรณ์ และส่งมอบงานสมบูรณ์</a:t>
-            </a:r>
-          </a:p>
-        </p:txBody>
-      </p:sp>
-    </p:spTree>
-  </p:cSld>
-  <p:clrMapOvr>
-    <a:masterClrMapping/>
-  </p:clrMapOvr>
-</p:sld>
-</file>
-
-<file path=ppt/slides/slide12.xml><?xml version="1.0" encoding="utf-8"?>
-<p:sld xmlns:a="http://schemas.openxmlformats.org/drawingml/2006/main" xmlns:p="http://schemas.openxmlformats.org/presentationml/2006/main" xmlns:r="http://schemas.openxmlformats.org/officeDocument/2006/relationships">
-  <p:cSld>
-    <p:bg>
-      <p:bgPr>
-        <a:solidFill>
-          <a:srgbClr val="EEF7F2"/>
-        </a:solidFill>
-        <a:effectLst/>
-      </p:bgPr>
-    </p:bg>
-    <p:spTree>
-      <p:nvGrpSpPr>
-        <p:cNvPr id="1" name=""/>
-        <p:cNvGrpSpPr/>
-        <p:nvPr/>
-      </p:nvGrpSpPr>
-      <p:grpSpPr/>
-      <p:sp>
-        <p:nvSpPr>
-          <p:cNvPr id="2" name="TextBox 1"/>
-          <p:cNvSpPr txBox="1"/>
-          <p:nvPr/>
-        </p:nvSpPr>
-        <p:spPr>
-          <a:xfrm>
-            <a:off x="731520" y="365760"/>
-            <a:ext cx="10698480" cy="320040"/>
-          </a:xfrm>
-          <a:prstGeom prst="rect">
-            <a:avLst/>
-          </a:prstGeom>
-          <a:noFill/>
-        </p:spPr>
-        <p:txBody>
-          <a:bodyPr wrap="square" lIns="0" tIns="0" rIns="0" bIns="0">
-            <a:spAutoFit/>
-          </a:bodyPr>
-          <a:lstStyle/>
-          <a:p>
-            <a:pPr>
-              <a:defRPr sz="1200" b="1">
-                <a:solidFill>
-                  <a:srgbClr val="52B788"/>
-                </a:solidFill>
-                <a:latin typeface="Segoe UI"/>
-              </a:defRPr>
-            </a:pPr>
-            <a:r>
               <a:t>EXPECTED IMPACT &amp; VALUE</a:t>
             </a:r>
           </a:p>
@@ -7026,7 +6392,7 @@
 </p:sld>
 </file>
 
-<file path=ppt/slides/slide13.xml><?xml version="1.0" encoding="utf-8"?>
+<file path=ppt/slides/slide12.xml><?xml version="1.0" encoding="utf-8"?>
 <p:sld xmlns:a="http://schemas.openxmlformats.org/drawingml/2006/main" xmlns:p="http://schemas.openxmlformats.org/presentationml/2006/main" xmlns:r="http://schemas.openxmlformats.org/officeDocument/2006/relationships">
   <p:cSld>
     <p:bg>

</xml_diff>

<commit_message>
Update Roadmap duration to '..... เดือน' as requested
</commit_message>
<xml_diff>
--- a/qsbg_smart_tour_presentation.pptx
+++ b/qsbg_smart_tour_presentation.pptx
@@ -674,7 +674,7 @@
           </a:p>
           <a:p>
             <a:r>
-              <a:t>แผนงาน 9 เดือน แบ่งเป็น 3 ระยะชัดเจน: Phase 1 สร้างฐานราก Core Foundation, Phase 2 ระบบ Realtime &amp; Mobile App, และ Phase 3 ฟังก์ชันขั้นสูงและการส่งมอบงานสมบูรณ์ มั่นใจได้ว่าส่งมอบตรงเวลาแน่นอนครับ</a:t>
+              <a:t>แผนงานแบ่งเป็น 3 ระยะชัดเจน (กรอบเวลา ..... เดือน): Phase 1 สร้างฐานราก Core Foundation, Phase 2 ระบบ Realtime &amp; Mobile App, และ Phase 3 ฟังก์ชันขั้นสูงและการส่งมอบงานสมบูรณ์ มั่นใจได้ว่าส่งมอบตรงเวลาแน่นอนครับ</a:t>
             </a:r>
           </a:p>
         </p:txBody>
@@ -4679,7 +4679,7 @@
               </a:defRPr>
             </a:pPr>
             <a:r>
-              <a:t>แผนงานการดำเนินงาน 3 ระยะ (กรอบเวลา 9 เดือน) | เอกสารประกอบการนำเสนอเชิงบริหาร</a:t>
+              <a:t>แผนงานการดำเนินงาน 3 ระยะ (กรอบเวลา ..... เดือน) | เอกสารประกอบการนำเสนอเชิงบริหาร</a:t>
             </a:r>
           </a:p>
         </p:txBody>
@@ -5438,7 +5438,7 @@
               </a:defRPr>
             </a:pPr>
             <a:r>
-              <a:t>แผนการดำเนินงานและส่งมอบโครงการ (กรอบเวลา 9 เดือน)</a:t>
+              <a:t>แผนการดำเนินงานและส่งมอบโครงการ (กรอบเวลา ..... เดือน)</a:t>
             </a:r>
           </a:p>
         </p:txBody>
@@ -5601,7 +5601,7 @@
               </a:defRPr>
             </a:pPr>
             <a:r>
-              <a:t>ระยะที่ 1 (เดือนที่ 1 - 3)</a:t>
+              <a:t>ระยะที่ 1 (Phase 1)</a:t>
             </a:r>
           </a:p>
           <a:p>
@@ -5853,7 +5853,7 @@
               </a:defRPr>
             </a:pPr>
             <a:r>
-              <a:t>ระยะที่ 2 (เดือนที่ 4 - 6)</a:t>
+              <a:t>ระยะที่ 2 (Phase 2)</a:t>
             </a:r>
           </a:p>
           <a:p>
@@ -6105,7 +6105,7 @@
               </a:defRPr>
             </a:pPr>
             <a:r>
-              <a:t>ระยะที่ 3 (เดือนที่ 7 - 9)</a:t>
+              <a:t>ระยะที่ 3 (Phase 3)</a:t>
             </a:r>
           </a:p>
           <a:p>

</xml_diff>

<commit_message>
Decorate slides with authentic Queen Sirikit Botanic Garden photos from Chillpainai
</commit_message>
<xml_diff>
--- a/qsbg_smart_tour_presentation.pptx
+++ b/qsbg_smart_tour_presentation.pptx
@@ -599,7 +599,7 @@
           </a:p>
           <a:p>
             <a:r>
-              <a:t>เทคโนโลยี Geofences ตอบโจทย์การเป็นสวนพฤกษศาสตร์เพื่อการเรียนรู้อย่างแท้จริงครับ เมื่อรถเข้าสู่พิกัดสำคัญ ระบบจะส่งข้อมูลความรู้และมัลติมีเดียขึ้นมาให้ชม เสมือนมีมัคคุเทศก์ส่วนตัวตลอดเส้นทางครับ</a:t>
+              <a:t>เทคโนโลยี Geofences ตอบโจทย์สวนพฤกษศาสตร์อย่างยิ่งครับ เมื่อรถเข้าพิกัดสำคัญ ระบบจะส่งข้อความแจ้งเตือน แนะนำพรรณไม้เด่น ประวัติความเป็นมา และข้อควรระวัง เสมือนมีมัคคุเทศก์ส่วนตัวตลอดเส้นทางครับ</a:t>
             </a:r>
           </a:p>
         </p:txBody>
@@ -824,7 +824,7 @@
           </a:p>
           <a:p>
             <a:r>
-              <a:t>สรุปในตอนท้าย โครงการพัฒนาระบบจัดการรถนำเที่ยวไฟฟ้า สวนพฤกษศาสตร์สมเด็จพระนางเจ้าสิริกิติ์ จะเป็นการผสานเทคโนโลยีสมัยใหม่เข้ากับธรรมชาติอย่างลงตัว ยกระดับการบริการ การจัดการ และความยั่งยืนในทุกมิติ ทางทีมงานมีความพร้อมทั้งด้านบุคลากรและเทคโนโลยีที่จะเริ่มดำเนินงานตามแผนงานระยะที่ 1 ทันทีครับ ขอขอบพระคุณคณะกรรมการทุกท่านเป็นอย่างสูงครับ</a:t>
+              <a:t>สรุปในตอนท้าย โครงการพัฒนาระบบจัดการรถนำเที่ยวไฟฟ้า สวนพฤกษศาสตร์สมเด็จพระนางเจ้าสิริกิติ์ เป็นการผสานเทคโนโลยีเข้ากับธรรมชาติอย่างลงตัว ยกระดับการบริการ การจัดการ และความยั่งยืนในทุกมิติ ทางทีมงานมีความพร้อมทั้งด้านบุคลากรและเทคโนโลยีที่จะดำเนินงานตามแผนงานระยะที่ 1 ทันทีครับ ขอขอบพระคุณคณะกรรมการทุกท่านเป็นอย่างสูงครับ</a:t>
             </a:r>
           </a:p>
         </p:txBody>
@@ -4606,7 +4606,7 @@
                 <a:solidFill>
                   <a:srgbClr val="52B788"/>
                 </a:solidFill>
-                <a:latin typeface="Segoe UI"/>
+                <a:latin typeface="Leelawadee UI"/>
               </a:defRPr>
             </a:pPr>
             <a:r>
@@ -4622,7 +4622,7 @@
                 <a:solidFill>
                   <a:srgbClr val="FFFFFF"/>
                 </a:solidFill>
-                <a:latin typeface="Segoe UI"/>
+                <a:latin typeface="Leelawadee UI"/>
               </a:defRPr>
             </a:pPr>
             <a:r>
@@ -4642,7 +4642,7 @@
                 <a:solidFill>
                   <a:srgbClr val="D8F3DC"/>
                 </a:solidFill>
-                <a:latin typeface="Segoe UI"/>
+                <a:latin typeface="Leelawadee UI"/>
               </a:defRPr>
             </a:pPr>
             <a:r>
@@ -4658,7 +4658,7 @@
                 <a:solidFill>
                   <a:srgbClr val="B7E4C7"/>
                 </a:solidFill>
-                <a:latin typeface="Segoe UI"/>
+                <a:latin typeface="Leelawadee UI"/>
               </a:defRPr>
             </a:pPr>
             <a:r>
@@ -4675,7 +4675,7 @@
                 <a:solidFill>
                   <a:srgbClr val="95D5B2"/>
                 </a:solidFill>
-                <a:latin typeface="Segoe UI"/>
+                <a:latin typeface="Leelawadee UI"/>
               </a:defRPr>
             </a:pPr>
             <a:r>
@@ -4783,7 +4783,7 @@
                 <a:solidFill>
                   <a:srgbClr val="FFFFFF"/>
                 </a:solidFill>
-                <a:latin typeface="Segoe UI"/>
+                <a:latin typeface="Leelawadee UI"/>
               </a:defRPr>
             </a:pPr>
             <a:r>
@@ -4799,7 +4799,7 @@
                 <a:solidFill>
                   <a:srgbClr val="D8F3DC"/>
                 </a:solidFill>
-                <a:latin typeface="Segoe UI"/>
+                <a:latin typeface="Leelawadee UI"/>
               </a:defRPr>
             </a:pPr>
             <a:r>
@@ -4815,7 +4815,7 @@
                 <a:solidFill>
                   <a:srgbClr val="D8F3DC"/>
                 </a:solidFill>
-                <a:latin typeface="Segoe UI"/>
+                <a:latin typeface="Leelawadee UI"/>
               </a:defRPr>
             </a:pPr>
             <a:r>
@@ -4831,7 +4831,7 @@
                 <a:solidFill>
                   <a:srgbClr val="D8F3DC"/>
                 </a:solidFill>
-                <a:latin typeface="Segoe UI"/>
+                <a:latin typeface="Leelawadee UI"/>
               </a:defRPr>
             </a:pPr>
             <a:r>
@@ -4893,7 +4893,7 @@
                 <a:solidFill>
                   <a:srgbClr val="52B788"/>
                 </a:solidFill>
-                <a:latin typeface="Segoe UI"/>
+                <a:latin typeface="Leelawadee UI"/>
               </a:defRPr>
             </a:pPr>
             <a:r>
@@ -4929,11 +4929,11 @@
                 <a:solidFill>
                   <a:srgbClr val="1B4332"/>
                 </a:solidFill>
-                <a:latin typeface="Segoe UI"/>
-              </a:defRPr>
-            </a:pPr>
-            <a:r>
-              <a:t>ระบบแนะนำแหล่งท่องเที่ยวตามพิกัดภูมิศาสตร์</a:t>
+                <a:latin typeface="Leelawadee UI"/>
+              </a:defRPr>
+            </a:pPr>
+            <a:r>
+              <a:t>ระบบแนะนำท่องเที่ยวตามพิกัดอัจฉริยะ</a:t>
             </a:r>
           </a:p>
         </p:txBody>
@@ -4965,11 +4965,11 @@
                 <a:solidFill>
                   <a:srgbClr val="5A646E"/>
                 </a:solidFill>
-                <a:latin typeface="Segoe UI"/>
-              </a:defRPr>
-            </a:pPr>
-            <a:r>
-              <a:t>การประยุกต์ใช้เทคโนโลยี Geofences เพื่อสนับสนุนการท่องเที่ยวเชิงเรียนรู้</a:t>
+                <a:latin typeface="Leelawadee UI"/>
+              </a:defRPr>
+            </a:pPr>
+            <a:r>
+              <a:t>การประยุกต์เทคโนโลยี Geofences เพื่อสนับสนุนการท่องเที่ยวเชิงนิเวศ</a:t>
             </a:r>
           </a:p>
         </p:txBody>
@@ -4983,7 +4983,7 @@
         <p:spPr>
           <a:xfrm>
             <a:off x="731520" y="1691640"/>
-            <a:ext cx="5120640" cy="4480560"/>
+            <a:ext cx="4846320" cy="4572000"/>
           </a:xfrm>
           <a:prstGeom prst="roundRect">
             <a:avLst/>
@@ -5027,8 +5027,8 @@
         </p:nvSpPr>
         <p:spPr>
           <a:xfrm>
-            <a:off x="1005840" y="1920240"/>
-            <a:ext cx="4572000" cy="4023360"/>
+            <a:off x="960120" y="1874519"/>
+            <a:ext cx="4389120" cy="4114800"/>
           </a:xfrm>
           <a:prstGeom prst="rect">
             <a:avLst/>
@@ -5049,7 +5049,7 @@
                 <a:solidFill>
                   <a:srgbClr val="1B4332"/>
                 </a:solidFill>
-                <a:latin typeface="Segoe UI"/>
+                <a:latin typeface="Leelawadee UI"/>
               </a:defRPr>
             </a:pPr>
             <a:r>
@@ -5062,7 +5062,7 @@
                 <a:solidFill>
                   <a:srgbClr val="134074"/>
                 </a:solidFill>
-                <a:latin typeface="Segoe UI"/>
+                <a:latin typeface="Leelawadee UI"/>
               </a:defRPr>
             </a:pPr>
             <a:r>
@@ -5078,11 +5078,11 @@
                 <a:solidFill>
                   <a:srgbClr val="14181B"/>
                 </a:solidFill>
-                <a:latin typeface="Segoe UI"/>
-              </a:defRPr>
-            </a:pPr>
-            <a:r>
-              <a:t>กำหนดพื้นที่พิกัดจำลองล้อมรอบจุดท่องเที่ยวสำคัญ เมื่อยานพาหนะเข้าสู่พื้นที่ ระบบจะระบุตำแหน่งโดยอัตโนมัติ</a:t>
+                <a:latin typeface="Leelawadee UI"/>
+              </a:defRPr>
+            </a:pPr>
+            <a:r>
+              <a:t>กำหนดพื้นที่พิกัดล้อมรอบจุดท่องเที่ยวสำคัญ เมื่อยานพาหนะหรือนักท่องเที่ยวผ่านเข้ามา ระบบจะระบุตำแหน่งอัตโนมัติ</a:t>
             </a:r>
           </a:p>
           <a:p>
@@ -5091,11 +5091,11 @@
                 <a:solidFill>
                   <a:srgbClr val="134074"/>
                 </a:solidFill>
-                <a:latin typeface="Segoe UI"/>
-              </a:defRPr>
-            </a:pPr>
-            <a:r>
-              <a:t>• ระบบมัลติมีเดียและข้อมูลพรรณไม้อัตโนมัติ</a:t>
+                <a:latin typeface="Leelawadee UI"/>
+              </a:defRPr>
+            </a:pPr>
+            <a:r>
+              <a:t>• ระบบส่งต่อข้อมูลพรรณไม้อัตโนมัติ</a:t>
             </a:r>
           </a:p>
           <a:p>
@@ -5107,11 +5107,11 @@
                 <a:solidFill>
                   <a:srgbClr val="14181B"/>
                 </a:solidFill>
-                <a:latin typeface="Segoe UI"/>
-              </a:defRPr>
-            </a:pPr>
-            <a:r>
-              <a:t>ส่งมอบข้อมูลความรู้ พันธุ์ไม้เด่นประจำโซน และประวัติความเป็นมา แสดงผลขึ้นบนหน้าจอตามจุดที่ยืนอยู่จริง</a:t>
+                <a:latin typeface="Leelawadee UI"/>
+              </a:defRPr>
+            </a:pPr>
+            <a:r>
+              <a:t>ส่งข้อความแนะนำพันธุ์ไม้เด่นประจำโซน ข้อมูลนิเวศวิทยา และประวัติความเป็นมา แสดงผลขึ้นบนหน้าจอมือถือหรือแท็บเล็ตประจำรถ</a:t>
             </a:r>
           </a:p>
           <a:p>
@@ -5120,11 +5120,11 @@
                 <a:solidFill>
                   <a:srgbClr val="134074"/>
                 </a:solidFill>
-                <a:latin typeface="Segoe UI"/>
-              </a:defRPr>
-            </a:pPr>
-            <a:r>
-              <a:t>• การแนะนำเส้นทางที่เหมาะสม (Smart Route)</a:t>
+                <a:latin typeface="Leelawadee UI"/>
+              </a:defRPr>
+            </a:pPr>
+            <a:r>
+              <a:t>• แนะนำเส้นทางท่องเที่ยว (Smart Route)</a:t>
             </a:r>
           </a:p>
           <a:p>
@@ -5136,11 +5136,11 @@
                 <a:solidFill>
                   <a:srgbClr val="14181B"/>
                 </a:solidFill>
-                <a:latin typeface="Segoe UI"/>
-              </a:defRPr>
-            </a:pPr>
-            <a:r>
-              <a:t>แนะนำเส้นทางท่องเที่ยวที่เหมาะสมตามเวลาที่มี เช่น เส้นทาง 1 ชั่วโมง หรือเส้นทางเจาะลึก 3 ชั่วโมง</a:t>
+                <a:latin typeface="Leelawadee UI"/>
+              </a:defRPr>
+            </a:pPr>
+            <a:r>
+              <a:t>แนะนำเส้นทางท่องเที่ยวที่เหมาะสมตามเวลา เช่น ทริปสั้น 1 ชม. หรือทริปเจาะลึก 3 ชม. ตอบโจทย์ผู้รักธรรมชาติ</a:t>
             </a:r>
           </a:p>
         </p:txBody>
@@ -5153,8 +5153,8 @@
         </p:nvSpPr>
         <p:spPr>
           <a:xfrm>
-            <a:off x="6217920" y="1691640"/>
-            <a:ext cx="5120640" cy="4480560"/>
+            <a:off x="5760720" y="1691640"/>
+            <a:ext cx="5760720" cy="4572000"/>
           </a:xfrm>
           <a:prstGeom prst="roundRect">
             <a:avLst/>
@@ -5198,8 +5198,8 @@
         </p:nvSpPr>
         <p:spPr>
           <a:xfrm>
-            <a:off x="6492240" y="1920240"/>
-            <a:ext cx="4572000" cy="4023360"/>
+            <a:off x="5989320" y="1828800"/>
+            <a:ext cx="5303520" cy="2514600"/>
           </a:xfrm>
           <a:prstGeom prst="rect">
             <a:avLst/>
@@ -5214,26 +5214,26 @@
           <a:p>
             <a:pPr>
               <a:spcAft>
-                <a:spcPts val="1400"/>
-              </a:spcAft>
-              <a:defRPr sz="1700" b="1">
+                <a:spcPts val="600"/>
+              </a:spcAft>
+              <a:defRPr sz="1650" b="1">
                 <a:solidFill>
                   <a:srgbClr val="1B4332"/>
                 </a:solidFill>
-                <a:latin typeface="Segoe UI"/>
-              </a:defRPr>
-            </a:pPr>
-            <a:r>
-              <a:t>จุดแลนด์มาร์กสำคัญที่เชื่อมโยงในระบบ</a:t>
-            </a:r>
-          </a:p>
-          <a:p>
-            <a:pPr>
-              <a:defRPr sz="1350" b="1">
+                <a:latin typeface="Leelawadee UI"/>
+              </a:defRPr>
+            </a:pPr>
+            <a:r>
+              <a:t>จุดแลนด์มาร์กสำคัญในระบบ</a:t>
+            </a:r>
+          </a:p>
+          <a:p>
+            <a:pPr>
+              <a:defRPr sz="1200" b="1">
                 <a:solidFill>
                   <a:srgbClr val="2D6A4F"/>
                 </a:solidFill>
-                <a:latin typeface="Segoe UI"/>
+                <a:latin typeface="Leelawadee UI"/>
               </a:defRPr>
             </a:pPr>
             <a:r>
@@ -5243,55 +5243,55 @@
           <a:p>
             <a:pPr>
               <a:spcAft>
-                <a:spcPts val="800"/>
-              </a:spcAft>
-              <a:defRPr sz="1150">
+                <a:spcPts val="400"/>
+              </a:spcAft>
+              <a:defRPr sz="1050">
                 <a:solidFill>
                   <a:srgbClr val="14181B"/>
                 </a:solidFill>
-                <a:latin typeface="Segoe UI"/>
-              </a:defRPr>
-            </a:pPr>
-            <a:r>
-              <a:t>ทางเดินลอยฟ้าศึกษาธรรมชาติเรือนยอดไม้ที่ยาวที่สุด นำเสนอข้อมูลพรรณไม้ระดับเรือนยอดและทัศนียภาพป่าดอยแม่ริม</a:t>
-            </a:r>
-          </a:p>
-          <a:p>
-            <a:pPr>
-              <a:defRPr sz="1350" b="1">
+                <a:latin typeface="Leelawadee UI"/>
+              </a:defRPr>
+            </a:pPr>
+            <a:r>
+              <a:t>ทางเดินลอยฟ้าศึกษาธรรมชาติเรือนยอดไม้ที่ยาวที่สุด แนะนำข้อมูลพรรณไม้ยอดไม้และทัศนียภาพป่าดอย</a:t>
+            </a:r>
+          </a:p>
+          <a:p>
+            <a:pPr>
+              <a:defRPr sz="1200" b="1">
                 <a:solidFill>
                   <a:srgbClr val="2D6A4F"/>
                 </a:solidFill>
-                <a:latin typeface="Segoe UI"/>
-              </a:defRPr>
-            </a:pPr>
-            <a:r>
-              <a:t>2. กลุ่มอาคารเรือนกระจกเฉลิมพระเกียรติ</a:t>
-            </a:r>
-          </a:p>
-          <a:p>
-            <a:pPr>
-              <a:spcAft>
-                <a:spcPts val="800"/>
-              </a:spcAft>
-              <a:defRPr sz="1150">
+                <a:latin typeface="Leelawadee UI"/>
+              </a:defRPr>
+            </a:pPr>
+            <a:r>
+              <a:t>2. กลุ่มอาคารเรือนกระจก</a:t>
+            </a:r>
+          </a:p>
+          <a:p>
+            <a:pPr>
+              <a:spcAft>
+                <a:spcPts val="400"/>
+              </a:spcAft>
+              <a:defRPr sz="1050">
                 <a:solidFill>
                   <a:srgbClr val="14181B"/>
                 </a:solidFill>
-                <a:latin typeface="Segoe UI"/>
-              </a:defRPr>
-            </a:pPr>
-            <a:r>
-              <a:t>รวบรวมพืชทนแล้ง พืชป่าดงดิบ พืชกินแมลง และบัวนานาชนิด นำเสนอข้อมูลความรู้ทางพฤกษศาสตร์เชิงลึก</a:t>
-            </a:r>
-          </a:p>
-          <a:p>
-            <a:pPr>
-              <a:defRPr sz="1350" b="1">
+                <a:latin typeface="Leelawadee UI"/>
+              </a:defRPr>
+            </a:pPr>
+            <a:r>
+              <a:t>รวบรวมพืชทนแล้ง พืชป่าดิบชื้น พืชกินแมลง และบัวนานาชนิด แนะนำข้อมูลทางพฤกษศาสตร์เชิงลึก</a:t>
+            </a:r>
+          </a:p>
+          <a:p>
+            <a:pPr>
+              <a:defRPr sz="1200" b="1">
                 <a:solidFill>
                   <a:srgbClr val="2D6A4F"/>
                 </a:solidFill>
-                <a:latin typeface="Segoe UI"/>
+                <a:latin typeface="Leelawadee UI"/>
               </a:defRPr>
             </a:pPr>
             <a:r>
@@ -5301,26 +5301,26 @@
           <a:p>
             <a:pPr>
               <a:spcAft>
-                <a:spcPts val="800"/>
-              </a:spcAft>
-              <a:defRPr sz="1150">
+                <a:spcPts val="400"/>
+              </a:spcAft>
+              <a:defRPr sz="1050">
                 <a:solidFill>
                   <a:srgbClr val="14181B"/>
                 </a:solidFill>
-                <a:latin typeface="Segoe UI"/>
-              </a:defRPr>
-            </a:pPr>
-            <a:r>
-              <a:t>แหล่งเรียนรู้และนิทรรศการถาวรด้านความหลากหลายทางชีวภาพ เหมาะสำหรับการเรียนรู้ของนักเรียนและครอบครัว</a:t>
-            </a:r>
-          </a:p>
-          <a:p>
-            <a:pPr>
-              <a:defRPr sz="1350" b="1">
+                <a:latin typeface="Leelawadee UI"/>
+              </a:defRPr>
+            </a:pPr>
+            <a:r>
+              <a:t>แหล่งเรียนรู้และนิทรรศการความหลากหลายทางชีวภาพ เหมาะสำหรับกลุ่มนักเรียนและครอบครัว</a:t>
+            </a:r>
+          </a:p>
+          <a:p>
+            <a:pPr>
+              <a:defRPr sz="1200" b="1">
                 <a:solidFill>
                   <a:srgbClr val="2D6A4F"/>
                 </a:solidFill>
-                <a:latin typeface="Segoe UI"/>
+                <a:latin typeface="Leelawadee UI"/>
               </a:defRPr>
             </a:pPr>
             <a:r>
@@ -5330,17 +5330,254 @@
           <a:p>
             <a:pPr>
               <a:spcAft>
-                <a:spcPts val="800"/>
-              </a:spcAft>
-              <a:defRPr sz="1150">
+                <a:spcPts val="400"/>
+              </a:spcAft>
+              <a:defRPr sz="1050">
                 <a:solidFill>
                   <a:srgbClr val="14181B"/>
                 </a:solidFill>
-                <a:latin typeface="Segoe UI"/>
-              </a:defRPr>
-            </a:pPr>
-            <a:r>
-              <a:t>พื้นที่ศึกษาธรรมชาติเชิงอนุรักษ์ จุดชมทัศนียภาพ และพื้นที่จัดกิจกรรมสิ่งแวดล้อมศึกษา</a:t>
+                <a:latin typeface="Leelawadee UI"/>
+              </a:defRPr>
+            </a:pPr>
+            <a:r>
+              <a:t>พื้นที่ศึกษาธรรมชาติริมลำธาร จุดชมวิวทิวทัศน์ และพื้นที่จัดกิจกรรมสิ่งแวดล้อมศึกษา</a:t>
+            </a:r>
+          </a:p>
+        </p:txBody>
+      </p:sp>
+      <p:pic>
+        <p:nvPicPr>
+          <p:cNvPr id="9" name="Picture 8" descr="landmark_canopy_walkway.jpg"/>
+          <p:cNvPicPr>
+            <a:picLocks noChangeAspect="1"/>
+          </p:cNvPicPr>
+          <p:nvPr/>
+        </p:nvPicPr>
+        <p:blipFill>
+          <a:blip r:embed="rId2"/>
+          <a:stretch>
+            <a:fillRect/>
+          </a:stretch>
+        </p:blipFill>
+        <p:spPr>
+          <a:xfrm>
+            <a:off x="5989320" y="4434840"/>
+            <a:ext cx="1691640" cy="1115568"/>
+          </a:xfrm>
+          <a:prstGeom prst="rect">
+            <a:avLst/>
+          </a:prstGeom>
+        </p:spPr>
+      </p:pic>
+      <p:sp>
+        <p:nvSpPr>
+          <p:cNvPr id="10" name="Rounded Rectangle 9"/>
+          <p:cNvSpPr/>
+          <p:nvPr/>
+        </p:nvSpPr>
+        <p:spPr>
+          <a:xfrm>
+            <a:off x="5989320" y="5614416"/>
+            <a:ext cx="1691640" cy="292608"/>
+          </a:xfrm>
+          <a:prstGeom prst="roundRect">
+            <a:avLst/>
+          </a:prstGeom>
+          <a:solidFill>
+            <a:srgbClr val="EBF8F0"/>
+          </a:solidFill>
+          <a:ln w="10160">
+            <a:solidFill>
+              <a:srgbClr val="B7E4C7"/>
+            </a:solidFill>
+          </a:ln>
+        </p:spPr>
+        <p:style>
+          <a:lnRef idx="1">
+            <a:schemeClr val="accent1"/>
+          </a:lnRef>
+          <a:fillRef idx="3">
+            <a:schemeClr val="accent1"/>
+          </a:fillRef>
+          <a:effectRef idx="2">
+            <a:schemeClr val="accent1"/>
+          </a:effectRef>
+          <a:fontRef idx="minor">
+            <a:schemeClr val="lt1"/>
+          </a:fontRef>
+        </p:style>
+        <p:txBody>
+          <a:bodyPr rtlCol="0" anchor="ctr" wrap="none" lIns="0" tIns="0" rIns="0" bIns="0"/>
+          <a:lstStyle/>
+          <a:p>
+            <a:pPr algn="ctr">
+              <a:defRPr sz="900" b="1">
+                <a:solidFill>
+                  <a:srgbClr val="1B4332"/>
+                </a:solidFill>
+                <a:latin typeface="Tahoma"/>
+              </a:defRPr>
+            </a:pPr>
+            <a:r>
+              <a:t>Canopy Walkway</a:t>
+            </a:r>
+          </a:p>
+        </p:txBody>
+      </p:sp>
+      <p:pic>
+        <p:nvPicPr>
+          <p:cNvPr id="11" name="Picture 10" descr="landmark_glasshouse.jpg"/>
+          <p:cNvPicPr>
+            <a:picLocks noChangeAspect="1"/>
+          </p:cNvPicPr>
+          <p:nvPr/>
+        </p:nvPicPr>
+        <p:blipFill>
+          <a:blip r:embed="rId3"/>
+          <a:stretch>
+            <a:fillRect/>
+          </a:stretch>
+        </p:blipFill>
+        <p:spPr>
+          <a:xfrm>
+            <a:off x="7845552" y="4434840"/>
+            <a:ext cx="1691640" cy="1115568"/>
+          </a:xfrm>
+          <a:prstGeom prst="rect">
+            <a:avLst/>
+          </a:prstGeom>
+        </p:spPr>
+      </p:pic>
+      <p:sp>
+        <p:nvSpPr>
+          <p:cNvPr id="12" name="Rounded Rectangle 11"/>
+          <p:cNvSpPr/>
+          <p:nvPr/>
+        </p:nvSpPr>
+        <p:spPr>
+          <a:xfrm>
+            <a:off x="7845552" y="5614416"/>
+            <a:ext cx="1691640" cy="292608"/>
+          </a:xfrm>
+          <a:prstGeom prst="roundRect">
+            <a:avLst/>
+          </a:prstGeom>
+          <a:solidFill>
+            <a:srgbClr val="EBF8F0"/>
+          </a:solidFill>
+          <a:ln w="10160">
+            <a:solidFill>
+              <a:srgbClr val="B7E4C7"/>
+            </a:solidFill>
+          </a:ln>
+        </p:spPr>
+        <p:style>
+          <a:lnRef idx="1">
+            <a:schemeClr val="accent1"/>
+          </a:lnRef>
+          <a:fillRef idx="3">
+            <a:schemeClr val="accent1"/>
+          </a:fillRef>
+          <a:effectRef idx="2">
+            <a:schemeClr val="accent1"/>
+          </a:effectRef>
+          <a:fontRef idx="minor">
+            <a:schemeClr val="lt1"/>
+          </a:fontRef>
+        </p:style>
+        <p:txBody>
+          <a:bodyPr rtlCol="0" anchor="ctr" wrap="none" lIns="0" tIns="0" rIns="0" bIns="0"/>
+          <a:lstStyle/>
+          <a:p>
+            <a:pPr algn="ctr">
+              <a:defRPr sz="900" b="1">
+                <a:solidFill>
+                  <a:srgbClr val="1B4332"/>
+                </a:solidFill>
+                <a:latin typeface="Tahoma"/>
+              </a:defRPr>
+            </a:pPr>
+            <a:r>
+              <a:t>กลุ่มอาคารเรือนกระจก</a:t>
+            </a:r>
+          </a:p>
+        </p:txBody>
+      </p:sp>
+      <p:pic>
+        <p:nvPicPr>
+          <p:cNvPr id="13" name="Picture 12" descr="landmark_museum.jpg"/>
+          <p:cNvPicPr>
+            <a:picLocks noChangeAspect="1"/>
+          </p:cNvPicPr>
+          <p:nvPr/>
+        </p:nvPicPr>
+        <p:blipFill>
+          <a:blip r:embed="rId4"/>
+          <a:stretch>
+            <a:fillRect/>
+          </a:stretch>
+        </p:blipFill>
+        <p:spPr>
+          <a:xfrm>
+            <a:off x="9701784" y="4434840"/>
+            <a:ext cx="1691640" cy="1115568"/>
+          </a:xfrm>
+          <a:prstGeom prst="rect">
+            <a:avLst/>
+          </a:prstGeom>
+        </p:spPr>
+      </p:pic>
+      <p:sp>
+        <p:nvSpPr>
+          <p:cNvPr id="14" name="Rounded Rectangle 13"/>
+          <p:cNvSpPr/>
+          <p:nvPr/>
+        </p:nvSpPr>
+        <p:spPr>
+          <a:xfrm>
+            <a:off x="9701784" y="5614416"/>
+            <a:ext cx="1691640" cy="292608"/>
+          </a:xfrm>
+          <a:prstGeom prst="roundRect">
+            <a:avLst/>
+          </a:prstGeom>
+          <a:solidFill>
+            <a:srgbClr val="EBF8F0"/>
+          </a:solidFill>
+          <a:ln w="10160">
+            <a:solidFill>
+              <a:srgbClr val="B7E4C7"/>
+            </a:solidFill>
+          </a:ln>
+        </p:spPr>
+        <p:style>
+          <a:lnRef idx="1">
+            <a:schemeClr val="accent1"/>
+          </a:lnRef>
+          <a:fillRef idx="3">
+            <a:schemeClr val="accent1"/>
+          </a:fillRef>
+          <a:effectRef idx="2">
+            <a:schemeClr val="accent1"/>
+          </a:effectRef>
+          <a:fontRef idx="minor">
+            <a:schemeClr val="lt1"/>
+          </a:fontRef>
+        </p:style>
+        <p:txBody>
+          <a:bodyPr rtlCol="0" anchor="ctr" wrap="none" lIns="0" tIns="0" rIns="0" bIns="0"/>
+          <a:lstStyle/>
+          <a:p>
+            <a:pPr algn="ctr">
+              <a:defRPr sz="900" b="1">
+                <a:solidFill>
+                  <a:srgbClr val="1B4332"/>
+                </a:solidFill>
+                <a:latin typeface="Tahoma"/>
+              </a:defRPr>
+            </a:pPr>
+            <a:r>
+              <a:t>พิพิธภัณฑ์ธรรมชาติวิทยา</a:t>
             </a:r>
           </a:p>
         </p:txBody>
@@ -5398,7 +5635,7 @@
                 <a:solidFill>
                   <a:srgbClr val="52B788"/>
                 </a:solidFill>
-                <a:latin typeface="Segoe UI"/>
+                <a:latin typeface="Leelawadee UI"/>
               </a:defRPr>
             </a:pPr>
             <a:r>
@@ -5434,7 +5671,7 @@
                 <a:solidFill>
                   <a:srgbClr val="1B4332"/>
                 </a:solidFill>
-                <a:latin typeface="Segoe UI"/>
+                <a:latin typeface="Leelawadee UI"/>
               </a:defRPr>
             </a:pPr>
             <a:r>
@@ -5470,7 +5707,7 @@
                 <a:solidFill>
                   <a:srgbClr val="5A646E"/>
                 </a:solidFill>
-                <a:latin typeface="Segoe UI"/>
+                <a:latin typeface="Leelawadee UI"/>
               </a:defRPr>
             </a:pPr>
             <a:r>
@@ -5597,7 +5834,7 @@
                 <a:solidFill>
                   <a:srgbClr val="0B2545"/>
                 </a:solidFill>
-                <a:latin typeface="Segoe UI"/>
+                <a:latin typeface="Leelawadee UI"/>
               </a:defRPr>
             </a:pPr>
             <a:r>
@@ -5610,7 +5847,7 @@
                 <a:solidFill>
                   <a:srgbClr val="1B4332"/>
                 </a:solidFill>
-                <a:latin typeface="Segoe UI"/>
+                <a:latin typeface="Leelawadee UI"/>
               </a:defRPr>
             </a:pPr>
             <a:r>
@@ -5626,7 +5863,7 @@
                 <a:solidFill>
                   <a:srgbClr val="5A646E"/>
                 </a:solidFill>
-                <a:latin typeface="Segoe UI"/>
+                <a:latin typeface="Leelawadee UI"/>
               </a:defRPr>
             </a:pPr>
             <a:r>
@@ -5642,7 +5879,7 @@
                 <a:solidFill>
                   <a:srgbClr val="14181B"/>
                 </a:solidFill>
-                <a:latin typeface="Segoe UI"/>
+                <a:latin typeface="Leelawadee UI"/>
               </a:defRPr>
             </a:pPr>
             <a:r>
@@ -5658,7 +5895,7 @@
                 <a:solidFill>
                   <a:srgbClr val="14181B"/>
                 </a:solidFill>
-                <a:latin typeface="Segoe UI"/>
+                <a:latin typeface="Leelawadee UI"/>
               </a:defRPr>
             </a:pPr>
             <a:r>
@@ -5674,7 +5911,7 @@
                 <a:solidFill>
                   <a:srgbClr val="14181B"/>
                 </a:solidFill>
-                <a:latin typeface="Segoe UI"/>
+                <a:latin typeface="Leelawadee UI"/>
               </a:defRPr>
             </a:pPr>
             <a:r>
@@ -5690,7 +5927,7 @@
                 <a:solidFill>
                   <a:srgbClr val="14181B"/>
                 </a:solidFill>
-                <a:latin typeface="Segoe UI"/>
+                <a:latin typeface="Leelawadee UI"/>
               </a:defRPr>
             </a:pPr>
             <a:r>
@@ -5706,7 +5943,7 @@
                 <a:solidFill>
                   <a:srgbClr val="14181B"/>
                 </a:solidFill>
-                <a:latin typeface="Segoe UI"/>
+                <a:latin typeface="Leelawadee UI"/>
               </a:defRPr>
             </a:pPr>
             <a:r>
@@ -5722,7 +5959,7 @@
                 <a:solidFill>
                   <a:srgbClr val="14181B"/>
                 </a:solidFill>
-                <a:latin typeface="Segoe UI"/>
+                <a:latin typeface="Leelawadee UI"/>
               </a:defRPr>
             </a:pPr>
             <a:r>
@@ -5849,7 +6086,7 @@
                 <a:solidFill>
                   <a:srgbClr val="2D6A4F"/>
                 </a:solidFill>
-                <a:latin typeface="Segoe UI"/>
+                <a:latin typeface="Leelawadee UI"/>
               </a:defRPr>
             </a:pPr>
             <a:r>
@@ -5862,7 +6099,7 @@
                 <a:solidFill>
                   <a:srgbClr val="1B4332"/>
                 </a:solidFill>
-                <a:latin typeface="Segoe UI"/>
+                <a:latin typeface="Leelawadee UI"/>
               </a:defRPr>
             </a:pPr>
             <a:r>
@@ -5878,7 +6115,7 @@
                 <a:solidFill>
                   <a:srgbClr val="5A646E"/>
                 </a:solidFill>
-                <a:latin typeface="Segoe UI"/>
+                <a:latin typeface="Leelawadee UI"/>
               </a:defRPr>
             </a:pPr>
             <a:r>
@@ -5894,7 +6131,7 @@
                 <a:solidFill>
                   <a:srgbClr val="14181B"/>
                 </a:solidFill>
-                <a:latin typeface="Segoe UI"/>
+                <a:latin typeface="Leelawadee UI"/>
               </a:defRPr>
             </a:pPr>
             <a:r>
@@ -5910,7 +6147,7 @@
                 <a:solidFill>
                   <a:srgbClr val="14181B"/>
                 </a:solidFill>
-                <a:latin typeface="Segoe UI"/>
+                <a:latin typeface="Leelawadee UI"/>
               </a:defRPr>
             </a:pPr>
             <a:r>
@@ -5926,7 +6163,7 @@
                 <a:solidFill>
                   <a:srgbClr val="14181B"/>
                 </a:solidFill>
-                <a:latin typeface="Segoe UI"/>
+                <a:latin typeface="Leelawadee UI"/>
               </a:defRPr>
             </a:pPr>
             <a:r>
@@ -5942,7 +6179,7 @@
                 <a:solidFill>
                   <a:srgbClr val="14181B"/>
                 </a:solidFill>
-                <a:latin typeface="Segoe UI"/>
+                <a:latin typeface="Leelawadee UI"/>
               </a:defRPr>
             </a:pPr>
             <a:r>
@@ -5958,7 +6195,7 @@
                 <a:solidFill>
                   <a:srgbClr val="14181B"/>
                 </a:solidFill>
-                <a:latin typeface="Segoe UI"/>
+                <a:latin typeface="Leelawadee UI"/>
               </a:defRPr>
             </a:pPr>
             <a:r>
@@ -5974,7 +6211,7 @@
                 <a:solidFill>
                   <a:srgbClr val="14181B"/>
                 </a:solidFill>
-                <a:latin typeface="Segoe UI"/>
+                <a:latin typeface="Leelawadee UI"/>
               </a:defRPr>
             </a:pPr>
             <a:r>
@@ -6101,7 +6338,7 @@
                 <a:solidFill>
                   <a:srgbClr val="1B4332"/>
                 </a:solidFill>
-                <a:latin typeface="Segoe UI"/>
+                <a:latin typeface="Leelawadee UI"/>
               </a:defRPr>
             </a:pPr>
             <a:r>
@@ -6114,7 +6351,7 @@
                 <a:solidFill>
                   <a:srgbClr val="1B4332"/>
                 </a:solidFill>
-                <a:latin typeface="Segoe UI"/>
+                <a:latin typeface="Leelawadee UI"/>
               </a:defRPr>
             </a:pPr>
             <a:r>
@@ -6130,7 +6367,7 @@
                 <a:solidFill>
                   <a:srgbClr val="5A646E"/>
                 </a:solidFill>
-                <a:latin typeface="Segoe UI"/>
+                <a:latin typeface="Leelawadee UI"/>
               </a:defRPr>
             </a:pPr>
             <a:r>
@@ -6146,7 +6383,7 @@
                 <a:solidFill>
                   <a:srgbClr val="14181B"/>
                 </a:solidFill>
-                <a:latin typeface="Segoe UI"/>
+                <a:latin typeface="Leelawadee UI"/>
               </a:defRPr>
             </a:pPr>
             <a:r>
@@ -6162,7 +6399,7 @@
                 <a:solidFill>
                   <a:srgbClr val="14181B"/>
                 </a:solidFill>
-                <a:latin typeface="Segoe UI"/>
+                <a:latin typeface="Leelawadee UI"/>
               </a:defRPr>
             </a:pPr>
             <a:r>
@@ -6178,7 +6415,7 @@
                 <a:solidFill>
                   <a:srgbClr val="14181B"/>
                 </a:solidFill>
-                <a:latin typeface="Segoe UI"/>
+                <a:latin typeface="Leelawadee UI"/>
               </a:defRPr>
             </a:pPr>
             <a:r>
@@ -6194,7 +6431,7 @@
                 <a:solidFill>
                   <a:srgbClr val="14181B"/>
                 </a:solidFill>
-                <a:latin typeface="Segoe UI"/>
+                <a:latin typeface="Leelawadee UI"/>
               </a:defRPr>
             </a:pPr>
             <a:r>
@@ -6210,7 +6447,7 @@
                 <a:solidFill>
                   <a:srgbClr val="14181B"/>
                 </a:solidFill>
-                <a:latin typeface="Segoe UI"/>
+                <a:latin typeface="Leelawadee UI"/>
               </a:defRPr>
             </a:pPr>
             <a:r>
@@ -6226,7 +6463,7 @@
                 <a:solidFill>
                   <a:srgbClr val="14181B"/>
                 </a:solidFill>
-                <a:latin typeface="Segoe UI"/>
+                <a:latin typeface="Leelawadee UI"/>
               </a:defRPr>
             </a:pPr>
             <a:r>
@@ -6288,7 +6525,7 @@
                 <a:solidFill>
                   <a:srgbClr val="52B788"/>
                 </a:solidFill>
-                <a:latin typeface="Segoe UI"/>
+                <a:latin typeface="Leelawadee UI"/>
               </a:defRPr>
             </a:pPr>
             <a:r>
@@ -6324,7 +6561,7 @@
                 <a:solidFill>
                   <a:srgbClr val="1B4332"/>
                 </a:solidFill>
-                <a:latin typeface="Segoe UI"/>
+                <a:latin typeface="Leelawadee UI"/>
               </a:defRPr>
             </a:pPr>
             <a:r>
@@ -6360,7 +6597,7 @@
                 <a:solidFill>
                   <a:srgbClr val="5A646E"/>
                 </a:solidFill>
-                <a:latin typeface="Segoe UI"/>
+                <a:latin typeface="Leelawadee UI"/>
               </a:defRPr>
             </a:pPr>
             <a:r>
@@ -6444,7 +6681,7 @@
                 <a:solidFill>
                   <a:srgbClr val="1B4332"/>
                 </a:solidFill>
-                <a:latin typeface="Segoe UI"/>
+                <a:latin typeface="Leelawadee UI"/>
               </a:defRPr>
             </a:pPr>
             <a:r>
@@ -6460,7 +6697,7 @@
                 <a:solidFill>
                   <a:srgbClr val="14181B"/>
                 </a:solidFill>
-                <a:latin typeface="Segoe UI"/>
+                <a:latin typeface="Leelawadee UI"/>
               </a:defRPr>
             </a:pPr>
             <a:r>
@@ -6476,7 +6713,7 @@
                 <a:solidFill>
                   <a:srgbClr val="14181B"/>
                 </a:solidFill>
-                <a:latin typeface="Segoe UI"/>
+                <a:latin typeface="Leelawadee UI"/>
               </a:defRPr>
             </a:pPr>
             <a:r>
@@ -6492,7 +6729,7 @@
                 <a:solidFill>
                   <a:srgbClr val="14181B"/>
                 </a:solidFill>
-                <a:latin typeface="Segoe UI"/>
+                <a:latin typeface="Leelawadee UI"/>
               </a:defRPr>
             </a:pPr>
             <a:r>
@@ -6508,7 +6745,7 @@
                 <a:solidFill>
                   <a:srgbClr val="14181B"/>
                 </a:solidFill>
-                <a:latin typeface="Segoe UI"/>
+                <a:latin typeface="Leelawadee UI"/>
               </a:defRPr>
             </a:pPr>
             <a:r>
@@ -6592,7 +6829,7 @@
                 <a:solidFill>
                   <a:srgbClr val="0B2545"/>
                 </a:solidFill>
-                <a:latin typeface="Segoe UI"/>
+                <a:latin typeface="Leelawadee UI"/>
               </a:defRPr>
             </a:pPr>
             <a:r>
@@ -6608,7 +6845,7 @@
                 <a:solidFill>
                   <a:srgbClr val="14181B"/>
                 </a:solidFill>
-                <a:latin typeface="Segoe UI"/>
+                <a:latin typeface="Leelawadee UI"/>
               </a:defRPr>
             </a:pPr>
             <a:r>
@@ -6624,7 +6861,7 @@
                 <a:solidFill>
                   <a:srgbClr val="14181B"/>
                 </a:solidFill>
-                <a:latin typeface="Segoe UI"/>
+                <a:latin typeface="Leelawadee UI"/>
               </a:defRPr>
             </a:pPr>
             <a:r>
@@ -6640,7 +6877,7 @@
                 <a:solidFill>
                   <a:srgbClr val="14181B"/>
                 </a:solidFill>
-                <a:latin typeface="Segoe UI"/>
+                <a:latin typeface="Leelawadee UI"/>
               </a:defRPr>
             </a:pPr>
             <a:r>
@@ -6656,7 +6893,7 @@
                 <a:solidFill>
                   <a:srgbClr val="14181B"/>
                 </a:solidFill>
-                <a:latin typeface="Segoe UI"/>
+                <a:latin typeface="Leelawadee UI"/>
               </a:defRPr>
             </a:pPr>
             <a:r>
@@ -6740,7 +6977,7 @@
                 <a:solidFill>
                   <a:srgbClr val="2D6A4F"/>
                 </a:solidFill>
-                <a:latin typeface="Segoe UI"/>
+                <a:latin typeface="Leelawadee UI"/>
               </a:defRPr>
             </a:pPr>
             <a:r>
@@ -6756,7 +6993,7 @@
                 <a:solidFill>
                   <a:srgbClr val="14181B"/>
                 </a:solidFill>
-                <a:latin typeface="Segoe UI"/>
+                <a:latin typeface="Leelawadee UI"/>
               </a:defRPr>
             </a:pPr>
             <a:r>
@@ -6772,7 +7009,7 @@
                 <a:solidFill>
                   <a:srgbClr val="14181B"/>
                 </a:solidFill>
-                <a:latin typeface="Segoe UI"/>
+                <a:latin typeface="Leelawadee UI"/>
               </a:defRPr>
             </a:pPr>
             <a:r>
@@ -6788,7 +7025,7 @@
                 <a:solidFill>
                   <a:srgbClr val="14181B"/>
                 </a:solidFill>
-                <a:latin typeface="Segoe UI"/>
+                <a:latin typeface="Leelawadee UI"/>
               </a:defRPr>
             </a:pPr>
             <a:r>
@@ -6804,7 +7041,7 @@
                 <a:solidFill>
                   <a:srgbClr val="14181B"/>
                 </a:solidFill>
-                <a:latin typeface="Segoe UI"/>
+                <a:latin typeface="Leelawadee UI"/>
               </a:defRPr>
             </a:pPr>
             <a:r>
@@ -6888,7 +7125,7 @@
                 <a:solidFill>
                   <a:srgbClr val="B45309"/>
                 </a:solidFill>
-                <a:latin typeface="Segoe UI"/>
+                <a:latin typeface="Leelawadee UI"/>
               </a:defRPr>
             </a:pPr>
             <a:r>
@@ -6904,7 +7141,7 @@
                 <a:solidFill>
                   <a:srgbClr val="14181B"/>
                 </a:solidFill>
-                <a:latin typeface="Segoe UI"/>
+                <a:latin typeface="Leelawadee UI"/>
               </a:defRPr>
             </a:pPr>
             <a:r>
@@ -6920,7 +7157,7 @@
                 <a:solidFill>
                   <a:srgbClr val="14181B"/>
                 </a:solidFill>
-                <a:latin typeface="Segoe UI"/>
+                <a:latin typeface="Leelawadee UI"/>
               </a:defRPr>
             </a:pPr>
             <a:r>
@@ -6936,7 +7173,7 @@
                 <a:solidFill>
                   <a:srgbClr val="14181B"/>
                 </a:solidFill>
-                <a:latin typeface="Segoe UI"/>
+                <a:latin typeface="Leelawadee UI"/>
               </a:defRPr>
             </a:pPr>
             <a:r>
@@ -6952,7 +7189,7 @@
                 <a:solidFill>
                   <a:srgbClr val="14181B"/>
                 </a:solidFill>
-                <a:latin typeface="Segoe UI"/>
+                <a:latin typeface="Leelawadee UI"/>
               </a:defRPr>
             </a:pPr>
             <a:r>
@@ -7062,8 +7299,8 @@
         </p:nvSpPr>
         <p:spPr>
           <a:xfrm>
-            <a:off x="1097280" y="1463040"/>
-            <a:ext cx="9875520" cy="4114800"/>
+            <a:off x="822960" y="1280160"/>
+            <a:ext cx="6583680" cy="4754880"/>
           </a:xfrm>
           <a:prstGeom prst="rect">
             <a:avLst/>
@@ -7084,7 +7321,7 @@
                 <a:solidFill>
                   <a:srgbClr val="52B788"/>
                 </a:solidFill>
-                <a:latin typeface="Segoe UI"/>
+                <a:latin typeface="Leelawadee UI"/>
               </a:defRPr>
             </a:pPr>
             <a:r>
@@ -7100,11 +7337,15 @@
                 <a:solidFill>
                   <a:srgbClr val="FFFFFF"/>
                 </a:solidFill>
-                <a:latin typeface="Segoe UI"/>
-              </a:defRPr>
-            </a:pPr>
-            <a:r>
-              <a:t>พร้อมก้าวสู่การเป็นสวนพฤกษศาสตร์ระดับโลกเพื่ออนาคตที่ยั่งยืน</a:t>
+                <a:latin typeface="Leelawadee UI"/>
+              </a:defRPr>
+            </a:pPr>
+            <a:r>
+              <a:t>สวนพฤกษศาสตร์ระดับโลก</a:t>
+            </a:r>
+            <a:br/>
+            <a:r>
+              <a:t>สู่อนาคตที่ยั่งยืน</a:t>
             </a:r>
           </a:p>
           <a:p>
@@ -7112,11 +7353,11 @@
               <a:spcAft>
                 <a:spcPts val="3600"/>
               </a:spcAft>
-              <a:defRPr sz="1600">
+              <a:defRPr sz="1500">
                 <a:solidFill>
                   <a:srgbClr val="D8F3DC"/>
                 </a:solidFill>
-                <a:latin typeface="Segoe UI"/>
+                <a:latin typeface="Leelawadee UI"/>
               </a:defRPr>
             </a:pPr>
             <a:r>
@@ -7133,11 +7374,167 @@
                 <a:solidFill>
                   <a:srgbClr val="B45309"/>
                 </a:solidFill>
-                <a:latin typeface="Segoe UI"/>
+                <a:latin typeface="Leelawadee UI"/>
               </a:defRPr>
             </a:pPr>
             <a:r>
               <a:t>ขอขอบพระคุณคณะกรรมการทุกท่าน  |  ช่วงถาม - ตอบ (Q &amp; A)</a:t>
+            </a:r>
+          </a:p>
+        </p:txBody>
+      </p:sp>
+      <p:sp>
+        <p:nvSpPr>
+          <p:cNvPr id="4" name="Rounded Rectangle 3"/>
+          <p:cNvSpPr/>
+          <p:nvPr/>
+        </p:nvSpPr>
+        <p:spPr>
+          <a:xfrm>
+            <a:off x="7589520" y="1280160"/>
+            <a:ext cx="4114800" cy="4754880"/>
+          </a:xfrm>
+          <a:prstGeom prst="roundRect">
+            <a:avLst/>
+          </a:prstGeom>
+          <a:solidFill>
+            <a:srgbClr val="0F2D21"/>
+          </a:solidFill>
+          <a:ln w="15240">
+            <a:solidFill>
+              <a:srgbClr val="52B788"/>
+            </a:solidFill>
+          </a:ln>
+        </p:spPr>
+        <p:style>
+          <a:lnRef idx="1">
+            <a:schemeClr val="accent1"/>
+          </a:lnRef>
+          <a:fillRef idx="3">
+            <a:schemeClr val="accent1"/>
+          </a:fillRef>
+          <a:effectRef idx="2">
+            <a:schemeClr val="accent1"/>
+          </a:effectRef>
+          <a:fontRef idx="minor">
+            <a:schemeClr val="lt1"/>
+          </a:fontRef>
+        </p:style>
+        <p:txBody>
+          <a:bodyPr rtlCol="0" anchor="ctr"/>
+          <a:lstStyle/>
+          <a:p>
+            <a:pPr algn="ctr"/>
+          </a:p>
+        </p:txBody>
+      </p:sp>
+      <p:pic>
+        <p:nvPicPr>
+          <p:cNvPr id="5" name="Picture 4" descr="landmark_panoramic_garden.jpg"/>
+          <p:cNvPicPr>
+            <a:picLocks noChangeAspect="1"/>
+          </p:cNvPicPr>
+          <p:nvPr/>
+        </p:nvPicPr>
+        <p:blipFill>
+          <a:blip r:embed="rId2"/>
+          <a:stretch>
+            <a:fillRect/>
+          </a:stretch>
+        </p:blipFill>
+        <p:spPr>
+          <a:xfrm>
+            <a:off x="7726679" y="1417320"/>
+            <a:ext cx="3840480" cy="2468880"/>
+          </a:xfrm>
+          <a:prstGeom prst="rect">
+            <a:avLst/>
+          </a:prstGeom>
+        </p:spPr>
+      </p:pic>
+      <p:sp>
+        <p:nvSpPr>
+          <p:cNvPr id="6" name="TextBox 5"/>
+          <p:cNvSpPr txBox="1"/>
+          <p:nvPr/>
+        </p:nvSpPr>
+        <p:spPr>
+          <a:xfrm>
+            <a:off x="7726679" y="4023360"/>
+            <a:ext cx="3840480" cy="1828800"/>
+          </a:xfrm>
+          <a:prstGeom prst="rect">
+            <a:avLst/>
+          </a:prstGeom>
+          <a:noFill/>
+        </p:spPr>
+        <p:txBody>
+          <a:bodyPr wrap="square">
+            <a:spAutoFit/>
+          </a:bodyPr>
+          <a:lstStyle/>
+          <a:p>
+            <a:pPr>
+              <a:spcAft>
+                <a:spcPts val="600"/>
+              </a:spcAft>
+              <a:defRPr sz="1400" b="1">
+                <a:solidFill>
+                  <a:srgbClr val="FFFFFF"/>
+                </a:solidFill>
+                <a:latin typeface="Leelawadee UI"/>
+              </a:defRPr>
+            </a:pPr>
+            <a:r>
+              <a:t>สวนพฤกษศาสตร์สมเด็จพระนางเจ้าสิริกิติ์</a:t>
+            </a:r>
+          </a:p>
+          <a:p>
+            <a:pPr>
+              <a:spcAft>
+                <a:spcPts val="400"/>
+              </a:spcAft>
+              <a:defRPr sz="1200">
+                <a:solidFill>
+                  <a:srgbClr val="D8F3DC"/>
+                </a:solidFill>
+                <a:latin typeface="Leelawadee UI"/>
+              </a:defRPr>
+            </a:pPr>
+            <a:r>
+              <a:t>• มาตรฐานสากลแห่งแรกของประเทศไทย</a:t>
+            </a:r>
+          </a:p>
+          <a:p>
+            <a:pPr>
+              <a:spcAft>
+                <a:spcPts val="400"/>
+              </a:spcAft>
+              <a:defRPr sz="1200">
+                <a:solidFill>
+                  <a:srgbClr val="D8F3DC"/>
+                </a:solidFill>
+                <a:latin typeface="Leelawadee UI"/>
+              </a:defRPr>
+            </a:pPr>
+            <a:r>
+              <a:t>• พื้นที่อนุรักษ์ธรรมชาติ 6,500 ไร่ เชียงใหม่</a:t>
+            </a:r>
+          </a:p>
+          <a:p>
+            <a:pPr>
+              <a:spcAft>
+                <a:spcPts val="400"/>
+              </a:spcAft>
+              <a:defRPr sz="1200">
+                <a:solidFill>
+                  <a:srgbClr val="D8F3DC"/>
+                </a:solidFill>
+                <a:latin typeface="Leelawadee UI"/>
+              </a:defRPr>
+            </a:pPr>
+            <a:r>
+              <a:t>• มุ่งสู่ Smart &amp; Green Eco-Tourism ยั่งยืน</a:t>
             </a:r>
           </a:p>
         </p:txBody>
@@ -7195,7 +7592,7 @@
                 <a:solidFill>
                   <a:srgbClr val="52B788"/>
                 </a:solidFill>
-                <a:latin typeface="Segoe UI"/>
+                <a:latin typeface="Leelawadee UI"/>
               </a:defRPr>
             </a:pPr>
             <a:r>
@@ -7231,7 +7628,7 @@
                 <a:solidFill>
                   <a:srgbClr val="1B4332"/>
                 </a:solidFill>
-                <a:latin typeface="Segoe UI"/>
+                <a:latin typeface="Leelawadee UI"/>
               </a:defRPr>
             </a:pPr>
             <a:r>
@@ -7267,7 +7664,7 @@
                 <a:solidFill>
                   <a:srgbClr val="5A646E"/>
                 </a:solidFill>
-                <a:latin typeface="Segoe UI"/>
+                <a:latin typeface="Leelawadee UI"/>
               </a:defRPr>
             </a:pPr>
             <a:r>
@@ -7351,7 +7748,7 @@
                 <a:solidFill>
                   <a:srgbClr val="1B4332"/>
                 </a:solidFill>
-                <a:latin typeface="Segoe UI"/>
+                <a:latin typeface="Leelawadee UI"/>
               </a:defRPr>
             </a:pPr>
             <a:r>
@@ -7364,7 +7761,7 @@
                 <a:solidFill>
                   <a:srgbClr val="14181B"/>
                 </a:solidFill>
-                <a:latin typeface="Segoe UI"/>
+                <a:latin typeface="Leelawadee UI"/>
               </a:defRPr>
             </a:pPr>
             <a:r>
@@ -7380,7 +7777,7 @@
                 <a:solidFill>
                   <a:srgbClr val="5A646E"/>
                 </a:solidFill>
-                <a:latin typeface="Segoe UI"/>
+                <a:latin typeface="Leelawadee UI"/>
               </a:defRPr>
             </a:pPr>
             <a:r>
@@ -7396,7 +7793,7 @@
                 <a:solidFill>
                   <a:srgbClr val="14181B"/>
                 </a:solidFill>
-                <a:latin typeface="Segoe UI"/>
+                <a:latin typeface="Leelawadee UI"/>
               </a:defRPr>
             </a:pPr>
             <a:r>
@@ -7412,7 +7809,7 @@
                 <a:solidFill>
                   <a:srgbClr val="14181B"/>
                 </a:solidFill>
-                <a:latin typeface="Segoe UI"/>
+                <a:latin typeface="Leelawadee UI"/>
               </a:defRPr>
             </a:pPr>
             <a:r>
@@ -7428,7 +7825,7 @@
                 <a:solidFill>
                   <a:srgbClr val="14181B"/>
                 </a:solidFill>
-                <a:latin typeface="Segoe UI"/>
+                <a:latin typeface="Leelawadee UI"/>
               </a:defRPr>
             </a:pPr>
             <a:r>
@@ -7444,7 +7841,7 @@
                 <a:solidFill>
                   <a:srgbClr val="14181B"/>
                 </a:solidFill>
-                <a:latin typeface="Segoe UI"/>
+                <a:latin typeface="Leelawadee UI"/>
               </a:defRPr>
             </a:pPr>
             <a:r>
@@ -7528,7 +7925,7 @@
                 <a:solidFill>
                   <a:srgbClr val="134074"/>
                 </a:solidFill>
-                <a:latin typeface="Segoe UI"/>
+                <a:latin typeface="Leelawadee UI"/>
               </a:defRPr>
             </a:pPr>
             <a:r>
@@ -7541,7 +7938,7 @@
                 <a:solidFill>
                   <a:srgbClr val="14181B"/>
                 </a:solidFill>
-                <a:latin typeface="Segoe UI"/>
+                <a:latin typeface="Leelawadee UI"/>
               </a:defRPr>
             </a:pPr>
             <a:r>
@@ -7557,7 +7954,7 @@
                 <a:solidFill>
                   <a:srgbClr val="5A646E"/>
                 </a:solidFill>
-                <a:latin typeface="Segoe UI"/>
+                <a:latin typeface="Leelawadee UI"/>
               </a:defRPr>
             </a:pPr>
             <a:r>
@@ -7573,7 +7970,7 @@
                 <a:solidFill>
                   <a:srgbClr val="14181B"/>
                 </a:solidFill>
-                <a:latin typeface="Segoe UI"/>
+                <a:latin typeface="Leelawadee UI"/>
               </a:defRPr>
             </a:pPr>
             <a:r>
@@ -7589,7 +7986,7 @@
                 <a:solidFill>
                   <a:srgbClr val="14181B"/>
                 </a:solidFill>
-                <a:latin typeface="Segoe UI"/>
+                <a:latin typeface="Leelawadee UI"/>
               </a:defRPr>
             </a:pPr>
             <a:r>
@@ -7605,7 +8002,7 @@
                 <a:solidFill>
                   <a:srgbClr val="14181B"/>
                 </a:solidFill>
-                <a:latin typeface="Segoe UI"/>
+                <a:latin typeface="Leelawadee UI"/>
               </a:defRPr>
             </a:pPr>
             <a:r>
@@ -7621,7 +8018,7 @@
                 <a:solidFill>
                   <a:srgbClr val="14181B"/>
                 </a:solidFill>
-                <a:latin typeface="Segoe UI"/>
+                <a:latin typeface="Leelawadee UI"/>
               </a:defRPr>
             </a:pPr>
             <a:r>
@@ -7705,7 +8102,7 @@
                 <a:solidFill>
                   <a:srgbClr val="B45309"/>
                 </a:solidFill>
-                <a:latin typeface="Segoe UI"/>
+                <a:latin typeface="Leelawadee UI"/>
               </a:defRPr>
             </a:pPr>
             <a:r>
@@ -7718,7 +8115,7 @@
                 <a:solidFill>
                   <a:srgbClr val="14181B"/>
                 </a:solidFill>
-                <a:latin typeface="Segoe UI"/>
+                <a:latin typeface="Leelawadee UI"/>
               </a:defRPr>
             </a:pPr>
             <a:r>
@@ -7734,7 +8131,7 @@
                 <a:solidFill>
                   <a:srgbClr val="5A646E"/>
                 </a:solidFill>
-                <a:latin typeface="Segoe UI"/>
+                <a:latin typeface="Leelawadee UI"/>
               </a:defRPr>
             </a:pPr>
             <a:r>
@@ -7750,7 +8147,7 @@
                 <a:solidFill>
                   <a:srgbClr val="14181B"/>
                 </a:solidFill>
-                <a:latin typeface="Segoe UI"/>
+                <a:latin typeface="Leelawadee UI"/>
               </a:defRPr>
             </a:pPr>
             <a:r>
@@ -7766,7 +8163,7 @@
                 <a:solidFill>
                   <a:srgbClr val="14181B"/>
                 </a:solidFill>
-                <a:latin typeface="Segoe UI"/>
+                <a:latin typeface="Leelawadee UI"/>
               </a:defRPr>
             </a:pPr>
             <a:r>
@@ -7782,7 +8179,7 @@
                 <a:solidFill>
                   <a:srgbClr val="14181B"/>
                 </a:solidFill>
-                <a:latin typeface="Segoe UI"/>
+                <a:latin typeface="Leelawadee UI"/>
               </a:defRPr>
             </a:pPr>
             <a:r>
@@ -7798,7 +8195,7 @@
                 <a:solidFill>
                   <a:srgbClr val="14181B"/>
                 </a:solidFill>
-                <a:latin typeface="Segoe UI"/>
+                <a:latin typeface="Leelawadee UI"/>
               </a:defRPr>
             </a:pPr>
             <a:r>
@@ -7860,7 +8257,7 @@
                 <a:solidFill>
                   <a:srgbClr val="52B788"/>
                 </a:solidFill>
-                <a:latin typeface="Segoe UI"/>
+                <a:latin typeface="Leelawadee UI"/>
               </a:defRPr>
             </a:pPr>
             <a:r>
@@ -7896,7 +8293,7 @@
                 <a:solidFill>
                   <a:srgbClr val="1B4332"/>
                 </a:solidFill>
-                <a:latin typeface="Segoe UI"/>
+                <a:latin typeface="Leelawadee UI"/>
               </a:defRPr>
             </a:pPr>
             <a:r>
@@ -7932,7 +8329,7 @@
                 <a:solidFill>
                   <a:srgbClr val="5A646E"/>
                 </a:solidFill>
-                <a:latin typeface="Segoe UI"/>
+                <a:latin typeface="Leelawadee UI"/>
               </a:defRPr>
             </a:pPr>
             <a:r>
@@ -8016,7 +8413,7 @@
                 <a:solidFill>
                   <a:srgbClr val="1B4332"/>
                 </a:solidFill>
-                <a:latin typeface="Segoe UI"/>
+                <a:latin typeface="Leelawadee UI"/>
               </a:defRPr>
             </a:pPr>
             <a:r>
@@ -8032,7 +8429,7 @@
                 <a:solidFill>
                   <a:srgbClr val="134074"/>
                 </a:solidFill>
-                <a:latin typeface="Segoe UI"/>
+                <a:latin typeface="Leelawadee UI"/>
               </a:defRPr>
             </a:pPr>
             <a:r>
@@ -8048,7 +8445,7 @@
                 <a:solidFill>
                   <a:srgbClr val="14181B"/>
                 </a:solidFill>
-                <a:latin typeface="Segoe UI"/>
+                <a:latin typeface="Leelawadee UI"/>
               </a:defRPr>
             </a:pPr>
             <a:r>
@@ -8064,7 +8461,7 @@
                 <a:solidFill>
                   <a:srgbClr val="134074"/>
                 </a:solidFill>
-                <a:latin typeface="Segoe UI"/>
+                <a:latin typeface="Leelawadee UI"/>
               </a:defRPr>
             </a:pPr>
             <a:r>
@@ -8080,7 +8477,7 @@
                 <a:solidFill>
                   <a:srgbClr val="14181B"/>
                 </a:solidFill>
-                <a:latin typeface="Segoe UI"/>
+                <a:latin typeface="Leelawadee UI"/>
               </a:defRPr>
             </a:pPr>
             <a:r>
@@ -8188,7 +8585,7 @@
                 <a:solidFill>
                   <a:srgbClr val="1B4332"/>
                 </a:solidFill>
-                <a:latin typeface="Segoe UI"/>
+                <a:latin typeface="Leelawadee UI"/>
               </a:defRPr>
             </a:pPr>
             <a:r>
@@ -8201,7 +8598,7 @@
                 <a:solidFill>
                   <a:srgbClr val="14181B"/>
                 </a:solidFill>
-                <a:latin typeface="Segoe UI"/>
+                <a:latin typeface="Leelawadee UI"/>
               </a:defRPr>
             </a:pPr>
             <a:r>
@@ -8285,7 +8682,7 @@
                 <a:solidFill>
                   <a:srgbClr val="1B4332"/>
                 </a:solidFill>
-                <a:latin typeface="Segoe UI"/>
+                <a:latin typeface="Leelawadee UI"/>
               </a:defRPr>
             </a:pPr>
             <a:r>
@@ -8301,7 +8698,7 @@
                 <a:solidFill>
                   <a:srgbClr val="14181B"/>
                 </a:solidFill>
-                <a:latin typeface="Segoe UI"/>
+                <a:latin typeface="Leelawadee UI"/>
               </a:defRPr>
             </a:pPr>
             <a:r>
@@ -8317,7 +8714,7 @@
                 <a:solidFill>
                   <a:srgbClr val="14181B"/>
                 </a:solidFill>
-                <a:latin typeface="Segoe UI"/>
+                <a:latin typeface="Leelawadee UI"/>
               </a:defRPr>
             </a:pPr>
             <a:r>
@@ -8333,7 +8730,7 @@
                 <a:solidFill>
                   <a:srgbClr val="14181B"/>
                 </a:solidFill>
-                <a:latin typeface="Segoe UI"/>
+                <a:latin typeface="Leelawadee UI"/>
               </a:defRPr>
             </a:pPr>
             <a:r>
@@ -8395,7 +8792,7 @@
                 <a:solidFill>
                   <a:srgbClr val="52B788"/>
                 </a:solidFill>
-                <a:latin typeface="Segoe UI"/>
+                <a:latin typeface="Leelawadee UI"/>
               </a:defRPr>
             </a:pPr>
             <a:r>
@@ -8431,7 +8828,7 @@
                 <a:solidFill>
                   <a:srgbClr val="1B4332"/>
                 </a:solidFill>
-                <a:latin typeface="Segoe UI"/>
+                <a:latin typeface="Leelawadee UI"/>
               </a:defRPr>
             </a:pPr>
             <a:r>
@@ -8467,7 +8864,7 @@
                 <a:solidFill>
                   <a:srgbClr val="5A646E"/>
                 </a:solidFill>
-                <a:latin typeface="Segoe UI"/>
+                <a:latin typeface="Leelawadee UI"/>
               </a:defRPr>
             </a:pPr>
             <a:r>
@@ -8551,7 +8948,7 @@
                 <a:solidFill>
                   <a:srgbClr val="0B2545"/>
                 </a:solidFill>
-                <a:latin typeface="Segoe UI"/>
+                <a:latin typeface="Leelawadee UI"/>
               </a:defRPr>
             </a:pPr>
             <a:r>
@@ -8567,7 +8964,7 @@
                 <a:solidFill>
                   <a:srgbClr val="1B4332"/>
                 </a:solidFill>
-                <a:latin typeface="Segoe UI"/>
+                <a:latin typeface="Leelawadee UI"/>
               </a:defRPr>
             </a:pPr>
             <a:r>
@@ -8583,7 +8980,7 @@
                 <a:solidFill>
                   <a:srgbClr val="14181B"/>
                 </a:solidFill>
-                <a:latin typeface="Segoe UI"/>
+                <a:latin typeface="Leelawadee UI"/>
               </a:defRPr>
             </a:pPr>
             <a:r>
@@ -8599,7 +8996,7 @@
                 <a:solidFill>
                   <a:srgbClr val="1B4332"/>
                 </a:solidFill>
-                <a:latin typeface="Segoe UI"/>
+                <a:latin typeface="Leelawadee UI"/>
               </a:defRPr>
             </a:pPr>
             <a:r>
@@ -8612,7 +9009,7 @@
                 <a:solidFill>
                   <a:srgbClr val="14181B"/>
                 </a:solidFill>
-                <a:latin typeface="Segoe UI"/>
+                <a:latin typeface="Leelawadee UI"/>
               </a:defRPr>
             </a:pPr>
             <a:r>
@@ -8696,7 +9093,7 @@
                 <a:solidFill>
                   <a:srgbClr val="2D6A4F"/>
                 </a:solidFill>
-                <a:latin typeface="Segoe UI"/>
+                <a:latin typeface="Leelawadee UI"/>
               </a:defRPr>
             </a:pPr>
             <a:r>
@@ -8709,7 +9106,7 @@
                 <a:solidFill>
                   <a:srgbClr val="1B4332"/>
                 </a:solidFill>
-                <a:latin typeface="Segoe UI"/>
+                <a:latin typeface="Leelawadee UI"/>
               </a:defRPr>
             </a:pPr>
             <a:r>
@@ -8725,7 +9122,7 @@
                 <a:solidFill>
                   <a:srgbClr val="14181B"/>
                 </a:solidFill>
-                <a:latin typeface="Segoe UI"/>
+                <a:latin typeface="Leelawadee UI"/>
               </a:defRPr>
             </a:pPr>
             <a:r>
@@ -8738,7 +9135,7 @@
                 <a:solidFill>
                   <a:srgbClr val="1B4332"/>
                 </a:solidFill>
-                <a:latin typeface="Segoe UI"/>
+                <a:latin typeface="Leelawadee UI"/>
               </a:defRPr>
             </a:pPr>
             <a:r>
@@ -8751,7 +9148,7 @@
                 <a:solidFill>
                   <a:srgbClr val="14181B"/>
                 </a:solidFill>
-                <a:latin typeface="Segoe UI"/>
+                <a:latin typeface="Leelawadee UI"/>
               </a:defRPr>
             </a:pPr>
             <a:r>
@@ -8835,7 +9232,7 @@
                 <a:solidFill>
                   <a:srgbClr val="1B4332"/>
                 </a:solidFill>
-                <a:latin typeface="Segoe UI"/>
+                <a:latin typeface="Leelawadee UI"/>
               </a:defRPr>
             </a:pPr>
             <a:r>
@@ -8851,7 +9248,7 @@
                 <a:solidFill>
                   <a:srgbClr val="134074"/>
                 </a:solidFill>
-                <a:latin typeface="Segoe UI"/>
+                <a:latin typeface="Leelawadee UI"/>
               </a:defRPr>
             </a:pPr>
             <a:r>
@@ -8867,7 +9264,7 @@
                 <a:solidFill>
                   <a:srgbClr val="0B2545"/>
                 </a:solidFill>
-                <a:latin typeface="Segoe UI"/>
+                <a:latin typeface="Leelawadee UI"/>
               </a:defRPr>
             </a:pPr>
             <a:r>
@@ -8883,7 +9280,7 @@
                 <a:solidFill>
                   <a:srgbClr val="14181B"/>
                 </a:solidFill>
-                <a:latin typeface="Segoe UI"/>
+                <a:latin typeface="Leelawadee UI"/>
               </a:defRPr>
             </a:pPr>
             <a:r>
@@ -8899,7 +9296,7 @@
                 <a:solidFill>
                   <a:srgbClr val="0B2545"/>
                 </a:solidFill>
-                <a:latin typeface="Segoe UI"/>
+                <a:latin typeface="Leelawadee UI"/>
               </a:defRPr>
             </a:pPr>
             <a:r>
@@ -8915,7 +9312,7 @@
                 <a:solidFill>
                   <a:srgbClr val="14181B"/>
                 </a:solidFill>
-                <a:latin typeface="Segoe UI"/>
+                <a:latin typeface="Leelawadee UI"/>
               </a:defRPr>
             </a:pPr>
             <a:r>
@@ -8931,7 +9328,7 @@
                 <a:solidFill>
                   <a:srgbClr val="0B2545"/>
                 </a:solidFill>
-                <a:latin typeface="Segoe UI"/>
+                <a:latin typeface="Leelawadee UI"/>
               </a:defRPr>
             </a:pPr>
             <a:r>
@@ -8947,7 +9344,7 @@
                 <a:solidFill>
                   <a:srgbClr val="14181B"/>
                 </a:solidFill>
-                <a:latin typeface="Segoe UI"/>
+                <a:latin typeface="Leelawadee UI"/>
               </a:defRPr>
             </a:pPr>
             <a:r>
@@ -8963,7 +9360,7 @@
                 <a:solidFill>
                   <a:srgbClr val="0B2545"/>
                 </a:solidFill>
-                <a:latin typeface="Segoe UI"/>
+                <a:latin typeface="Leelawadee UI"/>
               </a:defRPr>
             </a:pPr>
             <a:r>
@@ -8979,7 +9376,7 @@
                 <a:solidFill>
                   <a:srgbClr val="14181B"/>
                 </a:solidFill>
-                <a:latin typeface="Segoe UI"/>
+                <a:latin typeface="Leelawadee UI"/>
               </a:defRPr>
             </a:pPr>
             <a:r>
@@ -8995,7 +9392,7 @@
                 <a:solidFill>
                   <a:srgbClr val="0B2545"/>
                 </a:solidFill>
-                <a:latin typeface="Segoe UI"/>
+                <a:latin typeface="Leelawadee UI"/>
               </a:defRPr>
             </a:pPr>
             <a:r>
@@ -9011,7 +9408,7 @@
                 <a:solidFill>
                   <a:srgbClr val="14181B"/>
                 </a:solidFill>
-                <a:latin typeface="Segoe UI"/>
+                <a:latin typeface="Leelawadee UI"/>
               </a:defRPr>
             </a:pPr>
             <a:r>
@@ -9027,7 +9424,7 @@
                 <a:solidFill>
                   <a:srgbClr val="0B2545"/>
                 </a:solidFill>
-                <a:latin typeface="Segoe UI"/>
+                <a:latin typeface="Leelawadee UI"/>
               </a:defRPr>
             </a:pPr>
             <a:r>
@@ -9043,7 +9440,7 @@
                 <a:solidFill>
                   <a:srgbClr val="14181B"/>
                 </a:solidFill>
-                <a:latin typeface="Segoe UI"/>
+                <a:latin typeface="Leelawadee UI"/>
               </a:defRPr>
             </a:pPr>
             <a:r>
@@ -9105,7 +9502,7 @@
                 <a:solidFill>
                   <a:srgbClr val="52B788"/>
                 </a:solidFill>
-                <a:latin typeface="Segoe UI"/>
+                <a:latin typeface="Leelawadee UI"/>
               </a:defRPr>
             </a:pPr>
             <a:r>
@@ -9141,7 +9538,7 @@
                 <a:solidFill>
                   <a:srgbClr val="1B4332"/>
                 </a:solidFill>
-                <a:latin typeface="Segoe UI"/>
+                <a:latin typeface="Leelawadee UI"/>
               </a:defRPr>
             </a:pPr>
             <a:r>
@@ -9177,7 +9574,7 @@
                 <a:solidFill>
                   <a:srgbClr val="5A646E"/>
                 </a:solidFill>
-                <a:latin typeface="Segoe UI"/>
+                <a:latin typeface="Leelawadee UI"/>
               </a:defRPr>
             </a:pPr>
             <a:r>
@@ -9301,7 +9698,7 @@
                 <a:solidFill>
                   <a:srgbClr val="0B2545"/>
                 </a:solidFill>
-                <a:latin typeface="Segoe UI"/>
+                <a:latin typeface="Leelawadee UI"/>
               </a:defRPr>
             </a:pPr>
             <a:r>
@@ -9317,7 +9714,7 @@
                 <a:solidFill>
                   <a:srgbClr val="14181B"/>
                 </a:solidFill>
-                <a:latin typeface="Segoe UI"/>
+                <a:latin typeface="Leelawadee UI"/>
               </a:defRPr>
             </a:pPr>
             <a:r>
@@ -9445,7 +9842,7 @@
                 <a:solidFill>
                   <a:srgbClr val="2D6A4F"/>
                 </a:solidFill>
-                <a:latin typeface="Segoe UI"/>
+                <a:latin typeface="Leelawadee UI"/>
               </a:defRPr>
             </a:pPr>
             <a:r>
@@ -9461,7 +9858,7 @@
                 <a:solidFill>
                   <a:srgbClr val="14181B"/>
                 </a:solidFill>
-                <a:latin typeface="Segoe UI"/>
+                <a:latin typeface="Leelawadee UI"/>
               </a:defRPr>
             </a:pPr>
             <a:r>
@@ -9589,7 +9986,7 @@
                 <a:solidFill>
                   <a:srgbClr val="134074"/>
                 </a:solidFill>
-                <a:latin typeface="Segoe UI"/>
+                <a:latin typeface="Leelawadee UI"/>
               </a:defRPr>
             </a:pPr>
             <a:r>
@@ -9605,7 +10002,7 @@
                 <a:solidFill>
                   <a:srgbClr val="14181B"/>
                 </a:solidFill>
-                <a:latin typeface="Segoe UI"/>
+                <a:latin typeface="Leelawadee UI"/>
               </a:defRPr>
             </a:pPr>
             <a:r>
@@ -9733,7 +10130,7 @@
                 <a:solidFill>
                   <a:srgbClr val="1B4332"/>
                 </a:solidFill>
-                <a:latin typeface="Segoe UI"/>
+                <a:latin typeface="Leelawadee UI"/>
               </a:defRPr>
             </a:pPr>
             <a:r>
@@ -9749,7 +10146,7 @@
                 <a:solidFill>
                   <a:srgbClr val="14181B"/>
                 </a:solidFill>
-                <a:latin typeface="Segoe UI"/>
+                <a:latin typeface="Leelawadee UI"/>
               </a:defRPr>
             </a:pPr>
             <a:r>
@@ -9815,7 +10212,7 @@
                 <a:solidFill>
                   <a:srgbClr val="52B788"/>
                 </a:solidFill>
-                <a:latin typeface="Segoe UI"/>
+                <a:latin typeface="Leelawadee UI"/>
               </a:defRPr>
             </a:pPr>
             <a:r>
@@ -9851,7 +10248,7 @@
                 <a:solidFill>
                   <a:srgbClr val="1B4332"/>
                 </a:solidFill>
-                <a:latin typeface="Segoe UI"/>
+                <a:latin typeface="Leelawadee UI"/>
               </a:defRPr>
             </a:pPr>
             <a:r>
@@ -9887,7 +10284,7 @@
                 <a:solidFill>
                   <a:srgbClr val="5A646E"/>
                 </a:solidFill>
-                <a:latin typeface="Segoe UI"/>
+                <a:latin typeface="Leelawadee UI"/>
               </a:defRPr>
             </a:pPr>
             <a:r>
@@ -9971,7 +10368,7 @@
                 <a:solidFill>
                   <a:srgbClr val="52B788"/>
                 </a:solidFill>
-                <a:latin typeface="Segoe UI"/>
+                <a:latin typeface="Leelawadee UI"/>
               </a:defRPr>
             </a:pPr>
             <a:r>
@@ -9984,7 +10381,7 @@
                 <a:solidFill>
                   <a:srgbClr val="1B4332"/>
                 </a:solidFill>
-                <a:latin typeface="Segoe UI"/>
+                <a:latin typeface="Leelawadee UI"/>
               </a:defRPr>
             </a:pPr>
             <a:r>
@@ -10000,7 +10397,7 @@
                 <a:solidFill>
                   <a:srgbClr val="5A646E"/>
                 </a:solidFill>
-                <a:latin typeface="Segoe UI"/>
+                <a:latin typeface="Leelawadee UI"/>
               </a:defRPr>
             </a:pPr>
             <a:r>
@@ -10016,7 +10413,7 @@
                 <a:solidFill>
                   <a:srgbClr val="14181B"/>
                 </a:solidFill>
-                <a:latin typeface="Segoe UI"/>
+                <a:latin typeface="Leelawadee UI"/>
               </a:defRPr>
             </a:pPr>
             <a:r>
@@ -10032,7 +10429,7 @@
                 <a:solidFill>
                   <a:srgbClr val="14181B"/>
                 </a:solidFill>
-                <a:latin typeface="Segoe UI"/>
+                <a:latin typeface="Leelawadee UI"/>
               </a:defRPr>
             </a:pPr>
             <a:r>
@@ -10048,7 +10445,7 @@
                 <a:solidFill>
                   <a:srgbClr val="14181B"/>
                 </a:solidFill>
-                <a:latin typeface="Segoe UI"/>
+                <a:latin typeface="Leelawadee UI"/>
               </a:defRPr>
             </a:pPr>
             <a:r>
@@ -10132,7 +10529,7 @@
                 <a:solidFill>
                   <a:srgbClr val="52B788"/>
                 </a:solidFill>
-                <a:latin typeface="Segoe UI"/>
+                <a:latin typeface="Leelawadee UI"/>
               </a:defRPr>
             </a:pPr>
             <a:r>
@@ -10145,7 +10542,7 @@
                 <a:solidFill>
                   <a:srgbClr val="1B4332"/>
                 </a:solidFill>
-                <a:latin typeface="Segoe UI"/>
+                <a:latin typeface="Leelawadee UI"/>
               </a:defRPr>
             </a:pPr>
             <a:r>
@@ -10161,7 +10558,7 @@
                 <a:solidFill>
                   <a:srgbClr val="5A646E"/>
                 </a:solidFill>
-                <a:latin typeface="Segoe UI"/>
+                <a:latin typeface="Leelawadee UI"/>
               </a:defRPr>
             </a:pPr>
             <a:r>
@@ -10177,7 +10574,7 @@
                 <a:solidFill>
                   <a:srgbClr val="14181B"/>
                 </a:solidFill>
-                <a:latin typeface="Segoe UI"/>
+                <a:latin typeface="Leelawadee UI"/>
               </a:defRPr>
             </a:pPr>
             <a:r>
@@ -10193,7 +10590,7 @@
                 <a:solidFill>
                   <a:srgbClr val="14181B"/>
                 </a:solidFill>
-                <a:latin typeface="Segoe UI"/>
+                <a:latin typeface="Leelawadee UI"/>
               </a:defRPr>
             </a:pPr>
             <a:r>
@@ -10209,7 +10606,7 @@
                 <a:solidFill>
                   <a:srgbClr val="14181B"/>
                 </a:solidFill>
-                <a:latin typeface="Segoe UI"/>
+                <a:latin typeface="Leelawadee UI"/>
               </a:defRPr>
             </a:pPr>
             <a:r>
@@ -10225,7 +10622,7 @@
                 <a:solidFill>
                   <a:srgbClr val="14181B"/>
                 </a:solidFill>
-                <a:latin typeface="Segoe UI"/>
+                <a:latin typeface="Leelawadee UI"/>
               </a:defRPr>
             </a:pPr>
             <a:r>
@@ -10309,7 +10706,7 @@
                 <a:solidFill>
                   <a:srgbClr val="52B788"/>
                 </a:solidFill>
-                <a:latin typeface="Segoe UI"/>
+                <a:latin typeface="Leelawadee UI"/>
               </a:defRPr>
             </a:pPr>
             <a:r>
@@ -10322,7 +10719,7 @@
                 <a:solidFill>
                   <a:srgbClr val="1B4332"/>
                 </a:solidFill>
-                <a:latin typeface="Segoe UI"/>
+                <a:latin typeface="Leelawadee UI"/>
               </a:defRPr>
             </a:pPr>
             <a:r>
@@ -10338,7 +10735,7 @@
                 <a:solidFill>
                   <a:srgbClr val="5A646E"/>
                 </a:solidFill>
-                <a:latin typeface="Segoe UI"/>
+                <a:latin typeface="Leelawadee UI"/>
               </a:defRPr>
             </a:pPr>
             <a:r>
@@ -10354,7 +10751,7 @@
                 <a:solidFill>
                   <a:srgbClr val="14181B"/>
                 </a:solidFill>
-                <a:latin typeface="Segoe UI"/>
+                <a:latin typeface="Leelawadee UI"/>
               </a:defRPr>
             </a:pPr>
             <a:r>
@@ -10370,7 +10767,7 @@
                 <a:solidFill>
                   <a:srgbClr val="14181B"/>
                 </a:solidFill>
-                <a:latin typeface="Segoe UI"/>
+                <a:latin typeface="Leelawadee UI"/>
               </a:defRPr>
             </a:pPr>
             <a:r>
@@ -10386,7 +10783,7 @@
                 <a:solidFill>
                   <a:srgbClr val="14181B"/>
                 </a:solidFill>
-                <a:latin typeface="Segoe UI"/>
+                <a:latin typeface="Leelawadee UI"/>
               </a:defRPr>
             </a:pPr>
             <a:r>
@@ -10470,7 +10867,7 @@
                 <a:solidFill>
                   <a:srgbClr val="52B788"/>
                 </a:solidFill>
-                <a:latin typeface="Segoe UI"/>
+                <a:latin typeface="Leelawadee UI"/>
               </a:defRPr>
             </a:pPr>
             <a:r>
@@ -10483,7 +10880,7 @@
                 <a:solidFill>
                   <a:srgbClr val="1B4332"/>
                 </a:solidFill>
-                <a:latin typeface="Segoe UI"/>
+                <a:latin typeface="Leelawadee UI"/>
               </a:defRPr>
             </a:pPr>
             <a:r>
@@ -10499,7 +10896,7 @@
                 <a:solidFill>
                   <a:srgbClr val="5A646E"/>
                 </a:solidFill>
-                <a:latin typeface="Segoe UI"/>
+                <a:latin typeface="Leelawadee UI"/>
               </a:defRPr>
             </a:pPr>
             <a:r>
@@ -10515,7 +10912,7 @@
                 <a:solidFill>
                   <a:srgbClr val="14181B"/>
                 </a:solidFill>
-                <a:latin typeface="Segoe UI"/>
+                <a:latin typeface="Leelawadee UI"/>
               </a:defRPr>
             </a:pPr>
             <a:r>
@@ -10531,7 +10928,7 @@
                 <a:solidFill>
                   <a:srgbClr val="14181B"/>
                 </a:solidFill>
-                <a:latin typeface="Segoe UI"/>
+                <a:latin typeface="Leelawadee UI"/>
               </a:defRPr>
             </a:pPr>
             <a:r>
@@ -10547,7 +10944,7 @@
                 <a:solidFill>
                   <a:srgbClr val="14181B"/>
                 </a:solidFill>
-                <a:latin typeface="Segoe UI"/>
+                <a:latin typeface="Leelawadee UI"/>
               </a:defRPr>
             </a:pPr>
             <a:r>
@@ -10631,7 +11028,7 @@
                 <a:solidFill>
                   <a:srgbClr val="52B788"/>
                 </a:solidFill>
-                <a:latin typeface="Segoe UI"/>
+                <a:latin typeface="Leelawadee UI"/>
               </a:defRPr>
             </a:pPr>
             <a:r>
@@ -10644,7 +11041,7 @@
                 <a:solidFill>
                   <a:srgbClr val="1B4332"/>
                 </a:solidFill>
-                <a:latin typeface="Segoe UI"/>
+                <a:latin typeface="Leelawadee UI"/>
               </a:defRPr>
             </a:pPr>
             <a:r>
@@ -10660,7 +11057,7 @@
                 <a:solidFill>
                   <a:srgbClr val="5A646E"/>
                 </a:solidFill>
-                <a:latin typeface="Segoe UI"/>
+                <a:latin typeface="Leelawadee UI"/>
               </a:defRPr>
             </a:pPr>
             <a:r>
@@ -10676,7 +11073,7 @@
                 <a:solidFill>
                   <a:srgbClr val="14181B"/>
                 </a:solidFill>
-                <a:latin typeface="Segoe UI"/>
+                <a:latin typeface="Leelawadee UI"/>
               </a:defRPr>
             </a:pPr>
             <a:r>
@@ -10692,7 +11089,7 @@
                 <a:solidFill>
                   <a:srgbClr val="14181B"/>
                 </a:solidFill>
-                <a:latin typeface="Segoe UI"/>
+                <a:latin typeface="Leelawadee UI"/>
               </a:defRPr>
             </a:pPr>
             <a:r>
@@ -10708,7 +11105,7 @@
                 <a:solidFill>
                   <a:srgbClr val="14181B"/>
                 </a:solidFill>
-                <a:latin typeface="Segoe UI"/>
+                <a:latin typeface="Leelawadee UI"/>
               </a:defRPr>
             </a:pPr>
             <a:r>
@@ -10792,7 +11189,7 @@
                 <a:solidFill>
                   <a:srgbClr val="1B4332"/>
                 </a:solidFill>
-                <a:latin typeface="Segoe UI"/>
+                <a:latin typeface="Leelawadee UI"/>
               </a:defRPr>
             </a:pPr>
             <a:r>
@@ -10805,7 +11202,7 @@
                 <a:solidFill>
                   <a:srgbClr val="14181B"/>
                 </a:solidFill>
-                <a:latin typeface="Segoe UI"/>
+                <a:latin typeface="Leelawadee UI"/>
               </a:defRPr>
             </a:pPr>
             <a:r>
@@ -10871,7 +11268,7 @@
                 <a:solidFill>
                   <a:srgbClr val="52B788"/>
                 </a:solidFill>
-                <a:latin typeface="Segoe UI"/>
+                <a:latin typeface="Leelawadee UI"/>
               </a:defRPr>
             </a:pPr>
             <a:r>
@@ -10907,7 +11304,7 @@
                 <a:solidFill>
                   <a:srgbClr val="1B4332"/>
                 </a:solidFill>
-                <a:latin typeface="Segoe UI"/>
+                <a:latin typeface="Leelawadee UI"/>
               </a:defRPr>
             </a:pPr>
             <a:r>
@@ -10943,7 +11340,7 @@
                 <a:solidFill>
                   <a:srgbClr val="5A646E"/>
                 </a:solidFill>
-                <a:latin typeface="Segoe UI"/>
+                <a:latin typeface="Leelawadee UI"/>
               </a:defRPr>
             </a:pPr>
             <a:r>
@@ -11027,7 +11424,7 @@
                 <a:solidFill>
                   <a:srgbClr val="0B2545"/>
                 </a:solidFill>
-                <a:latin typeface="Segoe UI"/>
+                <a:latin typeface="Leelawadee UI"/>
               </a:defRPr>
             </a:pPr>
             <a:r>
@@ -11043,7 +11440,7 @@
                 <a:solidFill>
                   <a:srgbClr val="14181B"/>
                 </a:solidFill>
-                <a:latin typeface="Segoe UI"/>
+                <a:latin typeface="Leelawadee UI"/>
               </a:defRPr>
             </a:pPr>
             <a:r>
@@ -11059,7 +11456,7 @@
                 <a:solidFill>
                   <a:srgbClr val="14181B"/>
                 </a:solidFill>
-                <a:latin typeface="Segoe UI"/>
+                <a:latin typeface="Leelawadee UI"/>
               </a:defRPr>
             </a:pPr>
             <a:r>
@@ -11075,7 +11472,7 @@
                 <a:solidFill>
                   <a:srgbClr val="14181B"/>
                 </a:solidFill>
-                <a:latin typeface="Segoe UI"/>
+                <a:latin typeface="Leelawadee UI"/>
               </a:defRPr>
             </a:pPr>
             <a:r>
@@ -11091,7 +11488,7 @@
                 <a:solidFill>
                   <a:srgbClr val="14181B"/>
                 </a:solidFill>
-                <a:latin typeface="Segoe UI"/>
+                <a:latin typeface="Leelawadee UI"/>
               </a:defRPr>
             </a:pPr>
             <a:r>
@@ -11175,7 +11572,7 @@
                 <a:solidFill>
                   <a:srgbClr val="2D6A4F"/>
                 </a:solidFill>
-                <a:latin typeface="Segoe UI"/>
+                <a:latin typeface="Leelawadee UI"/>
               </a:defRPr>
             </a:pPr>
             <a:r>
@@ -11191,7 +11588,7 @@
                 <a:solidFill>
                   <a:srgbClr val="14181B"/>
                 </a:solidFill>
-                <a:latin typeface="Segoe UI"/>
+                <a:latin typeface="Leelawadee UI"/>
               </a:defRPr>
             </a:pPr>
             <a:r>
@@ -11207,7 +11604,7 @@
                 <a:solidFill>
                   <a:srgbClr val="14181B"/>
                 </a:solidFill>
-                <a:latin typeface="Segoe UI"/>
+                <a:latin typeface="Leelawadee UI"/>
               </a:defRPr>
             </a:pPr>
             <a:r>
@@ -11223,7 +11620,7 @@
                 <a:solidFill>
                   <a:srgbClr val="14181B"/>
                 </a:solidFill>
-                <a:latin typeface="Segoe UI"/>
+                <a:latin typeface="Leelawadee UI"/>
               </a:defRPr>
             </a:pPr>
             <a:r>
@@ -11239,7 +11636,7 @@
                 <a:solidFill>
                   <a:srgbClr val="14181B"/>
                 </a:solidFill>
-                <a:latin typeface="Segoe UI"/>
+                <a:latin typeface="Leelawadee UI"/>
               </a:defRPr>
             </a:pPr>
             <a:r>
@@ -11323,7 +11720,7 @@
                 <a:solidFill>
                   <a:srgbClr val="1B4332"/>
                 </a:solidFill>
-                <a:latin typeface="Segoe UI"/>
+                <a:latin typeface="Leelawadee UI"/>
               </a:defRPr>
             </a:pPr>
             <a:r>
@@ -11339,7 +11736,7 @@
                 <a:solidFill>
                   <a:srgbClr val="14181B"/>
                 </a:solidFill>
-                <a:latin typeface="Segoe UI"/>
+                <a:latin typeface="Leelawadee UI"/>
               </a:defRPr>
             </a:pPr>
             <a:r>
@@ -11355,7 +11752,7 @@
                 <a:solidFill>
                   <a:srgbClr val="14181B"/>
                 </a:solidFill>
-                <a:latin typeface="Segoe UI"/>
+                <a:latin typeface="Leelawadee UI"/>
               </a:defRPr>
             </a:pPr>
             <a:r>
@@ -11371,7 +11768,7 @@
                 <a:solidFill>
                   <a:srgbClr val="14181B"/>
                 </a:solidFill>
-                <a:latin typeface="Segoe UI"/>
+                <a:latin typeface="Leelawadee UI"/>
               </a:defRPr>
             </a:pPr>
             <a:r>
@@ -11387,7 +11784,7 @@
                 <a:solidFill>
                   <a:srgbClr val="14181B"/>
                 </a:solidFill>
-                <a:latin typeface="Segoe UI"/>
+                <a:latin typeface="Leelawadee UI"/>
               </a:defRPr>
             </a:pPr>
             <a:r>
@@ -11471,7 +11868,7 @@
                 <a:solidFill>
                   <a:srgbClr val="B91C1C"/>
                 </a:solidFill>
-                <a:latin typeface="Segoe UI"/>
+                <a:latin typeface="Leelawadee UI"/>
               </a:defRPr>
             </a:pPr>
             <a:r>
@@ -11484,7 +11881,7 @@
                 <a:solidFill>
                   <a:srgbClr val="14181B"/>
                 </a:solidFill>
-                <a:latin typeface="Segoe UI"/>
+                <a:latin typeface="Leelawadee UI"/>
               </a:defRPr>
             </a:pPr>
             <a:r>
@@ -11550,7 +11947,7 @@
                 <a:solidFill>
                   <a:srgbClr val="52B788"/>
                 </a:solidFill>
-                <a:latin typeface="Segoe UI"/>
+                <a:latin typeface="Leelawadee UI"/>
               </a:defRPr>
             </a:pPr>
             <a:r>
@@ -11586,7 +11983,7 @@
                 <a:solidFill>
                   <a:srgbClr val="1B4332"/>
                 </a:solidFill>
-                <a:latin typeface="Segoe UI"/>
+                <a:latin typeface="Leelawadee UI"/>
               </a:defRPr>
             </a:pPr>
             <a:r>
@@ -11622,7 +12019,7 @@
                 <a:solidFill>
                   <a:srgbClr val="5A646E"/>
                 </a:solidFill>
-                <a:latin typeface="Segoe UI"/>
+                <a:latin typeface="Leelawadee UI"/>
               </a:defRPr>
             </a:pPr>
             <a:r>
@@ -11706,7 +12103,7 @@
                 <a:solidFill>
                   <a:srgbClr val="1B4332"/>
                 </a:solidFill>
-                <a:latin typeface="Segoe UI"/>
+                <a:latin typeface="Leelawadee UI"/>
               </a:defRPr>
             </a:pPr>
             <a:r>
@@ -11719,7 +12116,7 @@
                 <a:solidFill>
                   <a:srgbClr val="134074"/>
                 </a:solidFill>
-                <a:latin typeface="Segoe UI"/>
+                <a:latin typeface="Leelawadee UI"/>
               </a:defRPr>
             </a:pPr>
             <a:r>
@@ -11735,7 +12132,7 @@
                 <a:solidFill>
                   <a:srgbClr val="14181B"/>
                 </a:solidFill>
-                <a:latin typeface="Segoe UI"/>
+                <a:latin typeface="Leelawadee UI"/>
               </a:defRPr>
             </a:pPr>
             <a:r>
@@ -11748,7 +12145,7 @@
                 <a:solidFill>
                   <a:srgbClr val="134074"/>
                 </a:solidFill>
-                <a:latin typeface="Segoe UI"/>
+                <a:latin typeface="Leelawadee UI"/>
               </a:defRPr>
             </a:pPr>
             <a:r>
@@ -11764,7 +12161,7 @@
                 <a:solidFill>
                   <a:srgbClr val="14181B"/>
                 </a:solidFill>
-                <a:latin typeface="Segoe UI"/>
+                <a:latin typeface="Leelawadee UI"/>
               </a:defRPr>
             </a:pPr>
             <a:r>
@@ -11777,7 +12174,7 @@
                 <a:solidFill>
                   <a:srgbClr val="134074"/>
                 </a:solidFill>
-                <a:latin typeface="Segoe UI"/>
+                <a:latin typeface="Leelawadee UI"/>
               </a:defRPr>
             </a:pPr>
             <a:r>
@@ -11793,7 +12190,7 @@
                 <a:solidFill>
                   <a:srgbClr val="14181B"/>
                 </a:solidFill>
-                <a:latin typeface="Segoe UI"/>
+                <a:latin typeface="Leelawadee UI"/>
               </a:defRPr>
             </a:pPr>
             <a:r>
@@ -11806,7 +12203,7 @@
                 <a:solidFill>
                   <a:srgbClr val="134074"/>
                 </a:solidFill>
-                <a:latin typeface="Segoe UI"/>
+                <a:latin typeface="Leelawadee UI"/>
               </a:defRPr>
             </a:pPr>
             <a:r>
@@ -11822,7 +12219,7 @@
                 <a:solidFill>
                   <a:srgbClr val="14181B"/>
                 </a:solidFill>
-                <a:latin typeface="Segoe UI"/>
+                <a:latin typeface="Leelawadee UI"/>
               </a:defRPr>
             </a:pPr>
             <a:r>
@@ -11906,7 +12303,7 @@
                 <a:solidFill>
                   <a:srgbClr val="1B4332"/>
                 </a:solidFill>
-                <a:latin typeface="Segoe UI"/>
+                <a:latin typeface="Leelawadee UI"/>
               </a:defRPr>
             </a:pPr>
             <a:r>
@@ -11919,7 +12316,7 @@
                 <a:solidFill>
                   <a:srgbClr val="1B4332"/>
                 </a:solidFill>
-                <a:latin typeface="Segoe UI"/>
+                <a:latin typeface="Leelawadee UI"/>
               </a:defRPr>
             </a:pPr>
             <a:r>
@@ -11935,7 +12332,7 @@
                 <a:solidFill>
                   <a:srgbClr val="5A646E"/>
                 </a:solidFill>
-                <a:latin typeface="Segoe UI"/>
+                <a:latin typeface="Leelawadee UI"/>
               </a:defRPr>
             </a:pPr>
             <a:r>
@@ -11948,7 +12345,7 @@
                 <a:solidFill>
                   <a:srgbClr val="1B4332"/>
                 </a:solidFill>
-                <a:latin typeface="Segoe UI"/>
+                <a:latin typeface="Leelawadee UI"/>
               </a:defRPr>
             </a:pPr>
             <a:r>
@@ -11964,7 +12361,7 @@
                 <a:solidFill>
                   <a:srgbClr val="5A646E"/>
                 </a:solidFill>
-                <a:latin typeface="Segoe UI"/>
+                <a:latin typeface="Leelawadee UI"/>
               </a:defRPr>
             </a:pPr>
             <a:r>
@@ -11977,7 +12374,7 @@
                 <a:solidFill>
                   <a:srgbClr val="1B4332"/>
                 </a:solidFill>
-                <a:latin typeface="Segoe UI"/>
+                <a:latin typeface="Leelawadee UI"/>
               </a:defRPr>
             </a:pPr>
             <a:r>
@@ -11993,7 +12390,7 @@
                 <a:solidFill>
                   <a:srgbClr val="5A646E"/>
                 </a:solidFill>
-                <a:latin typeface="Segoe UI"/>
+                <a:latin typeface="Leelawadee UI"/>
               </a:defRPr>
             </a:pPr>
             <a:r>
@@ -12006,7 +12403,7 @@
                 <a:solidFill>
                   <a:srgbClr val="1B4332"/>
                 </a:solidFill>
-                <a:latin typeface="Segoe UI"/>
+                <a:latin typeface="Leelawadee UI"/>
               </a:defRPr>
             </a:pPr>
             <a:r>
@@ -12022,7 +12419,7 @@
                 <a:solidFill>
                   <a:srgbClr val="5A646E"/>
                 </a:solidFill>
-                <a:latin typeface="Segoe UI"/>
+                <a:latin typeface="Leelawadee UI"/>
               </a:defRPr>
             </a:pPr>
             <a:r>
@@ -12035,7 +12432,7 @@
                 <a:solidFill>
                   <a:srgbClr val="1B4332"/>
                 </a:solidFill>
-                <a:latin typeface="Segoe UI"/>
+                <a:latin typeface="Leelawadee UI"/>
               </a:defRPr>
             </a:pPr>
             <a:r>
@@ -12051,7 +12448,7 @@
                 <a:solidFill>
                   <a:srgbClr val="5A646E"/>
                 </a:solidFill>
-                <a:latin typeface="Segoe UI"/>
+                <a:latin typeface="Leelawadee UI"/>
               </a:defRPr>
             </a:pPr>
             <a:r>
@@ -12064,7 +12461,7 @@
                 <a:solidFill>
                   <a:srgbClr val="1B4332"/>
                 </a:solidFill>
-                <a:latin typeface="Segoe UI"/>
+                <a:latin typeface="Leelawadee UI"/>
               </a:defRPr>
             </a:pPr>
             <a:r>
@@ -12080,7 +12477,7 @@
                 <a:solidFill>
                   <a:srgbClr val="5A646E"/>
                 </a:solidFill>
-                <a:latin typeface="Segoe UI"/>
+                <a:latin typeface="Leelawadee UI"/>
               </a:defRPr>
             </a:pPr>
             <a:r>
@@ -12093,7 +12490,7 @@
                 <a:solidFill>
                   <a:srgbClr val="B45309"/>
                 </a:solidFill>
-                <a:latin typeface="Segoe UI"/>
+                <a:latin typeface="Leelawadee UI"/>
               </a:defRPr>
             </a:pPr>
             <a:r>
@@ -12198,7 +12595,7 @@
                 <a:solidFill>
                   <a:srgbClr val="14181B"/>
                 </a:solidFill>
-                <a:latin typeface="Segoe UI"/>
+                <a:latin typeface="Leelawadee UI"/>
               </a:defRPr>
             </a:pPr>
             <a:r>
@@ -12260,7 +12657,7 @@
                 <a:solidFill>
                   <a:srgbClr val="52B788"/>
                 </a:solidFill>
-                <a:latin typeface="Segoe UI"/>
+                <a:latin typeface="Leelawadee UI"/>
               </a:defRPr>
             </a:pPr>
             <a:r>
@@ -12296,7 +12693,7 @@
                 <a:solidFill>
                   <a:srgbClr val="1B4332"/>
                 </a:solidFill>
-                <a:latin typeface="Segoe UI"/>
+                <a:latin typeface="Leelawadee UI"/>
               </a:defRPr>
             </a:pPr>
             <a:r>
@@ -12332,7 +12729,7 @@
                 <a:solidFill>
                   <a:srgbClr val="5A646E"/>
                 </a:solidFill>
-                <a:latin typeface="Segoe UI"/>
+                <a:latin typeface="Leelawadee UI"/>
               </a:defRPr>
             </a:pPr>
             <a:r>
@@ -12416,7 +12813,7 @@
                 <a:solidFill>
                   <a:srgbClr val="52B788"/>
                 </a:solidFill>
-                <a:latin typeface="Segoe UI"/>
+                <a:latin typeface="Leelawadee UI"/>
               </a:defRPr>
             </a:pPr>
             <a:r>
@@ -12432,7 +12829,7 @@
                 <a:solidFill>
                   <a:srgbClr val="1B4332"/>
                 </a:solidFill>
-                <a:latin typeface="Segoe UI"/>
+                <a:latin typeface="Leelawadee UI"/>
               </a:defRPr>
             </a:pPr>
             <a:r>
@@ -12448,7 +12845,7 @@
                 <a:solidFill>
                   <a:srgbClr val="14181B"/>
                 </a:solidFill>
-                <a:latin typeface="Segoe UI"/>
+                <a:latin typeface="Leelawadee UI"/>
               </a:defRPr>
             </a:pPr>
             <a:r>
@@ -12461,7 +12858,7 @@
                 <a:solidFill>
                   <a:srgbClr val="134074"/>
                 </a:solidFill>
-                <a:latin typeface="Segoe UI"/>
+                <a:latin typeface="Leelawadee UI"/>
               </a:defRPr>
             </a:pPr>
             <a:r>
@@ -12545,7 +12942,7 @@
                 <a:solidFill>
                   <a:srgbClr val="52B788"/>
                 </a:solidFill>
-                <a:latin typeface="Segoe UI"/>
+                <a:latin typeface="Leelawadee UI"/>
               </a:defRPr>
             </a:pPr>
             <a:r>
@@ -12561,7 +12958,7 @@
                 <a:solidFill>
                   <a:srgbClr val="1B4332"/>
                 </a:solidFill>
-                <a:latin typeface="Segoe UI"/>
+                <a:latin typeface="Leelawadee UI"/>
               </a:defRPr>
             </a:pPr>
             <a:r>
@@ -12577,7 +12974,7 @@
                 <a:solidFill>
                   <a:srgbClr val="14181B"/>
                 </a:solidFill>
-                <a:latin typeface="Segoe UI"/>
+                <a:latin typeface="Leelawadee UI"/>
               </a:defRPr>
             </a:pPr>
             <a:r>
@@ -12598,7 +12995,7 @@
                 <a:solidFill>
                   <a:srgbClr val="134074"/>
                 </a:solidFill>
-                <a:latin typeface="Segoe UI"/>
+                <a:latin typeface="Leelawadee UI"/>
               </a:defRPr>
             </a:pPr>
             <a:r>
@@ -12682,7 +13079,7 @@
                 <a:solidFill>
                   <a:srgbClr val="52B788"/>
                 </a:solidFill>
-                <a:latin typeface="Segoe UI"/>
+                <a:latin typeface="Leelawadee UI"/>
               </a:defRPr>
             </a:pPr>
             <a:r>
@@ -12698,7 +13095,7 @@
                 <a:solidFill>
                   <a:srgbClr val="1B4332"/>
                 </a:solidFill>
-                <a:latin typeface="Segoe UI"/>
+                <a:latin typeface="Leelawadee UI"/>
               </a:defRPr>
             </a:pPr>
             <a:r>
@@ -12714,7 +13111,7 @@
                 <a:solidFill>
                   <a:srgbClr val="14181B"/>
                 </a:solidFill>
-                <a:latin typeface="Segoe UI"/>
+                <a:latin typeface="Leelawadee UI"/>
               </a:defRPr>
             </a:pPr>
             <a:r>
@@ -12727,7 +13124,7 @@
                 <a:solidFill>
                   <a:srgbClr val="134074"/>
                 </a:solidFill>
-                <a:latin typeface="Segoe UI"/>
+                <a:latin typeface="Leelawadee UI"/>
               </a:defRPr>
             </a:pPr>
             <a:r>

</xml_diff>

<commit_message>
Update Slide 2 Card 03: Holistic Data Integration for Modern Governance
</commit_message>
<xml_diff>
--- a/qsbg_smart_tour_presentation.pptx
+++ b/qsbg_smart_tour_presentation.pptx
@@ -8119,7 +8119,7 @@
               </a:defRPr>
             </a:pPr>
             <a:r>
-              <a:t>ขาดข้อมูลเชิงสถิติเพื่อการวางแผน</a:t>
+              <a:t>การบูรณาการข้อมูลองค์กรสมัยใหม่</a:t>
             </a:r>
           </a:p>
           <a:p>
@@ -8135,7 +8135,7 @@
               </a:defRPr>
             </a:pPr>
             <a:r>
-              <a:t>No Data-Driven Analytics</a:t>
+              <a:t>Holistic Data Integration for Modern Governance</a:t>
             </a:r>
           </a:p>
           <a:p>
@@ -8151,7 +8151,7 @@
               </a:defRPr>
             </a:pPr>
             <a:r>
-              <a:t>• ขาดระบบจัดเก็บข้อมูลการใช้บริการในรูปแบบดิจิทัล</a:t>
+              <a:t>• การพัฒนาองค์กรสมัยใหม่บนพื้นฐานเทคโนโลยีดิจิทัล ต้องการระบบจัดเก็บและบูรณาการข้อมูลแบบองค์รวม</a:t>
             </a:r>
           </a:p>
           <a:p>
@@ -8167,7 +8167,7 @@
               </a:defRPr>
             </a:pPr>
             <a:r>
-              <a:t>• ไม่มีข้อมูลเชิงพื้นที่และเวลา (Spatial Data) วิเคราะห์จุดหนาแน่น</a:t>
+              <a:t>• ข้อมูลต้องมีความถูกต้อง แม่นยำ เป็นปัจจุบัน และเรียกใช้ได้ตลอดเวลาในทุกแพลตฟอร์ม</a:t>
             </a:r>
           </a:p>
           <a:p>
@@ -8183,7 +8183,7 @@
               </a:defRPr>
             </a:pPr>
             <a:r>
-              <a:t>• ผู้บริหารไม่สามารถนำข้อมูลมาใช้วางแผนจัดสรรทรัพยากรได้อย่างแม่นยำ</a:t>
+              <a:t>• เชื่อมโยงข้อมูลการเดินรถ การจำหน่ายตั๋ว และการบริการเข้าสู่ฐานข้อมูลศูนย์กลาง</a:t>
             </a:r>
           </a:p>
           <a:p>
@@ -8199,7 +8199,7 @@
               </a:defRPr>
             </a:pPr>
             <a:r>
-              <a:t>• ระบบจำหน่ายตั๋วและการตรวจสอบยังไม่เชื่อมโยงกับฐานข้อมูลกลาง</a:t>
+              <a:t>• สนับสนุนการนำข้อมูลเชิงพื้นที่ (Spatial Data) มาวิเคราะห์เพื่อการวางแผนเชิงรุก</a:t>
             </a:r>
           </a:p>
         </p:txBody>

</xml_diff>